<commit_message>
Add reference database summary slide to PowerPoint (22 slides)
- New slide: "Reference Database — Full pLIN Assignment" showing:
  - 78,902 total sequences, 76,549 classified (97%), 33,143 unique pLIN codes
  - Hierarchical resolution: L1=33 to L6=33,143 clusters
  - Top 10 Inc group distribution table
  - Key stats: 78.4% singletons, largest cluster 3,035, mean 101 kb
- Updated title slide metrics: 78,902 plasmids, 33,143 pLIN codes, 64,891 AMR hits
</commit_message>
<xml_diff>
--- a/output/pLIN_Tool_Architecture.pptx
+++ b/output/pLIN_Tool_Architecture.pptx
@@ -26,6 +26,7 @@
     <p:sldId id="274" r:id="rId25"/>
     <p:sldId id="275" r:id="rId26"/>
     <p:sldId id="276" r:id="rId27"/>
+    <p:sldId id="277" r:id="rId28"/>
   </p:sldIdLst>
   <p:sldSz cx="12191695" cy="6858000" type="screen4x3"/>
   <p:notesSz cx="6858000" cy="9144000"/>
@@ -3268,7 +3269,7 @@
               </a:defRPr>
             </a:pPr>
             <a:r>
-              <a:t>6,998</a:t>
+              <a:t>78,902</a:t>
             </a:r>
           </a:p>
         </p:txBody>
@@ -3304,11 +3305,11 @@
               </a:defRPr>
             </a:pPr>
             <a:r>
-              <a:t>Training</a:t>
+              <a:t>Total Plasmids</a:t>
             </a:r>
             <a:br/>
             <a:r>
-              <a:t>Plasmids</a:t>
+              <a:t>Classified</a:t>
             </a:r>
           </a:p>
         </p:txBody>
@@ -3510,7 +3511,7 @@
               </a:defRPr>
             </a:pPr>
             <a:r>
-              <a:t>2,232</a:t>
+              <a:t>33,143</a:t>
             </a:r>
           </a:p>
         </p:txBody>
@@ -3752,7 +3753,7 @@
               </a:defRPr>
             </a:pPr>
             <a:r>
-              <a:t>27,465</a:t>
+              <a:t>64,891</a:t>
             </a:r>
           </a:p>
         </p:txBody>
@@ -27126,6 +27127,3362 @@
             </a:pPr>
             <a:r>
               <a:t>Total: 19 slides, 28+ features, full GUI integration</a:t>
+            </a:r>
+          </a:p>
+        </p:txBody>
+      </p:sp>
+    </p:spTree>
+  </p:cSld>
+  <p:clrMapOvr>
+    <a:masterClrMapping/>
+  </p:clrMapOvr>
+</p:sld>
+</file>
+
+<file path=ppt/slides/slide22.xml><?xml version="1.0" encoding="utf-8"?>
+<p:sld xmlns:a="http://schemas.openxmlformats.org/drawingml/2006/main" xmlns:p="http://schemas.openxmlformats.org/presentationml/2006/main" xmlns:r="http://schemas.openxmlformats.org/officeDocument/2006/relationships">
+  <p:cSld>
+    <p:bg>
+      <p:bgPr>
+        <a:solidFill>
+          <a:srgbClr val="FFFFFF"/>
+        </a:solidFill>
+        <a:effectLst/>
+      </p:bgPr>
+    </p:bg>
+    <p:spTree>
+      <p:nvGrpSpPr>
+        <p:cNvPr id="1" name=""/>
+        <p:cNvGrpSpPr/>
+        <p:nvPr/>
+      </p:nvGrpSpPr>
+      <p:grpSpPr/>
+      <p:sp>
+        <p:nvSpPr>
+          <p:cNvPr id="2" name="Rounded Rectangle 1"/>
+          <p:cNvSpPr/>
+          <p:nvPr/>
+        </p:nvSpPr>
+        <p:spPr>
+          <a:xfrm>
+            <a:off x="0" y="0"/>
+            <a:ext cx="12191695" cy="1097280"/>
+          </a:xfrm>
+          <a:prstGeom prst="roundRect">
+            <a:avLst/>
+          </a:prstGeom>
+          <a:solidFill>
+            <a:srgbClr val="0D47A1"/>
+          </a:solidFill>
+          <a:ln>
+            <a:noFill/>
+          </a:ln>
+        </p:spPr>
+        <p:style>
+          <a:lnRef idx="1">
+            <a:schemeClr val="accent1"/>
+          </a:lnRef>
+          <a:fillRef idx="3">
+            <a:schemeClr val="accent1"/>
+          </a:fillRef>
+          <a:effectRef idx="2">
+            <a:schemeClr val="accent1"/>
+          </a:effectRef>
+          <a:fontRef idx="minor">
+            <a:schemeClr val="lt1"/>
+          </a:fontRef>
+        </p:style>
+        <p:txBody>
+          <a:bodyPr rtlCol="0" anchor="ctr"/>
+          <a:lstStyle/>
+          <a:p>
+            <a:pPr algn="ctr"/>
+          </a:p>
+        </p:txBody>
+      </p:sp>
+      <p:sp>
+        <p:nvSpPr>
+          <p:cNvPr id="3" name="TextBox 2"/>
+          <p:cNvSpPr txBox="1"/>
+          <p:nvPr/>
+        </p:nvSpPr>
+        <p:spPr>
+          <a:xfrm>
+            <a:off x="548640" y="137160"/>
+            <a:ext cx="10972800" cy="548640"/>
+          </a:xfrm>
+          <a:prstGeom prst="rect">
+            <a:avLst/>
+          </a:prstGeom>
+          <a:noFill/>
+        </p:spPr>
+        <p:txBody>
+          <a:bodyPr wrap="square">
+            <a:spAutoFit/>
+          </a:bodyPr>
+          <a:lstStyle/>
+          <a:p>
+            <a:pPr algn="l">
+              <a:defRPr sz="3200" b="1">
+                <a:solidFill>
+                  <a:srgbClr val="FFFFFF"/>
+                </a:solidFill>
+                <a:latin typeface="Calibri"/>
+              </a:defRPr>
+            </a:pPr>
+            <a:r>
+              <a:t>Reference Database — Full pLIN Assignment</a:t>
+            </a:r>
+          </a:p>
+        </p:txBody>
+      </p:sp>
+      <p:sp>
+        <p:nvSpPr>
+          <p:cNvPr id="4" name="TextBox 3"/>
+          <p:cNvSpPr txBox="1"/>
+          <p:nvPr/>
+        </p:nvSpPr>
+        <p:spPr>
+          <a:xfrm>
+            <a:off x="548640" y="640080"/>
+            <a:ext cx="10972800" cy="365760"/>
+          </a:xfrm>
+          <a:prstGeom prst="rect">
+            <a:avLst/>
+          </a:prstGeom>
+          <a:noFill/>
+        </p:spPr>
+        <p:txBody>
+          <a:bodyPr wrap="square">
+            <a:spAutoFit/>
+          </a:bodyPr>
+          <a:lstStyle/>
+          <a:p>
+            <a:pPr algn="l">
+              <a:defRPr sz="1600" b="0">
+                <a:solidFill>
+                  <a:srgbClr val="BBDEFB"/>
+                </a:solidFill>
+                <a:latin typeface="Calibri"/>
+              </a:defRPr>
+            </a:pPr>
+            <a:r>
+              <a:t>78,902 plasmid sequences (6,998 training + 71,904 reference) classified and assigned pLIN codes</a:t>
+            </a:r>
+          </a:p>
+        </p:txBody>
+      </p:sp>
+      <p:sp>
+        <p:nvSpPr>
+          <p:cNvPr id="5" name="Rounded Rectangle 4"/>
+          <p:cNvSpPr/>
+          <p:nvPr/>
+        </p:nvSpPr>
+        <p:spPr>
+          <a:xfrm>
+            <a:off x="365760" y="1280160"/>
+            <a:ext cx="2011680" cy="1371600"/>
+          </a:xfrm>
+          <a:prstGeom prst="roundRect">
+            <a:avLst/>
+          </a:prstGeom>
+          <a:solidFill>
+            <a:srgbClr val="0D47A1"/>
+          </a:solidFill>
+          <a:ln w="25400">
+            <a:solidFill>
+              <a:srgbClr val="1E88E5"/>
+            </a:solidFill>
+          </a:ln>
+        </p:spPr>
+        <p:style>
+          <a:lnRef idx="1">
+            <a:schemeClr val="accent1"/>
+          </a:lnRef>
+          <a:fillRef idx="3">
+            <a:schemeClr val="accent1"/>
+          </a:fillRef>
+          <a:effectRef idx="2">
+            <a:schemeClr val="accent1"/>
+          </a:effectRef>
+          <a:fontRef idx="minor">
+            <a:schemeClr val="lt1"/>
+          </a:fontRef>
+        </p:style>
+        <p:txBody>
+          <a:bodyPr rtlCol="0" anchor="ctr"/>
+          <a:lstStyle/>
+          <a:p>
+            <a:pPr algn="ctr"/>
+          </a:p>
+        </p:txBody>
+      </p:sp>
+      <p:sp>
+        <p:nvSpPr>
+          <p:cNvPr id="6" name="TextBox 5"/>
+          <p:cNvSpPr txBox="1"/>
+          <p:nvPr/>
+        </p:nvSpPr>
+        <p:spPr>
+          <a:xfrm>
+            <a:off x="365760" y="1417320"/>
+            <a:ext cx="2011680" cy="548640"/>
+          </a:xfrm>
+          <a:prstGeom prst="rect">
+            <a:avLst/>
+          </a:prstGeom>
+          <a:noFill/>
+        </p:spPr>
+        <p:txBody>
+          <a:bodyPr wrap="square">
+            <a:spAutoFit/>
+          </a:bodyPr>
+          <a:lstStyle/>
+          <a:p>
+            <a:pPr algn="ctr">
+              <a:defRPr sz="3200" b="1">
+                <a:solidFill>
+                  <a:srgbClr val="FFFFFF"/>
+                </a:solidFill>
+                <a:latin typeface="Calibri"/>
+              </a:defRPr>
+            </a:pPr>
+            <a:r>
+              <a:t>78,902</a:t>
+            </a:r>
+          </a:p>
+        </p:txBody>
+      </p:sp>
+      <p:sp>
+        <p:nvSpPr>
+          <p:cNvPr id="7" name="TextBox 6"/>
+          <p:cNvSpPr txBox="1"/>
+          <p:nvPr/>
+        </p:nvSpPr>
+        <p:spPr>
+          <a:xfrm>
+            <a:off x="365760" y="2011680"/>
+            <a:ext cx="2011680" cy="548640"/>
+          </a:xfrm>
+          <a:prstGeom prst="rect">
+            <a:avLst/>
+          </a:prstGeom>
+          <a:noFill/>
+        </p:spPr>
+        <p:txBody>
+          <a:bodyPr wrap="square">
+            <a:spAutoFit/>
+          </a:bodyPr>
+          <a:lstStyle/>
+          <a:p>
+            <a:pPr algn="ctr">
+              <a:defRPr sz="1300" b="0">
+                <a:solidFill>
+                  <a:srgbClr val="BBDEFB"/>
+                </a:solidFill>
+                <a:latin typeface="Calibri"/>
+              </a:defRPr>
+            </a:pPr>
+            <a:r>
+              <a:t>Total</a:t>
+            </a:r>
+            <a:br/>
+            <a:r>
+              <a:t>Sequences</a:t>
+            </a:r>
+          </a:p>
+        </p:txBody>
+      </p:sp>
+      <p:sp>
+        <p:nvSpPr>
+          <p:cNvPr id="8" name="Rounded Rectangle 7"/>
+          <p:cNvSpPr/>
+          <p:nvPr/>
+        </p:nvSpPr>
+        <p:spPr>
+          <a:xfrm>
+            <a:off x="2651760" y="1280160"/>
+            <a:ext cx="2011680" cy="1371600"/>
+          </a:xfrm>
+          <a:prstGeom prst="roundRect">
+            <a:avLst/>
+          </a:prstGeom>
+          <a:solidFill>
+            <a:srgbClr val="0D47A1"/>
+          </a:solidFill>
+          <a:ln w="25400">
+            <a:solidFill>
+              <a:srgbClr val="1E88E5"/>
+            </a:solidFill>
+          </a:ln>
+        </p:spPr>
+        <p:style>
+          <a:lnRef idx="1">
+            <a:schemeClr val="accent1"/>
+          </a:lnRef>
+          <a:fillRef idx="3">
+            <a:schemeClr val="accent1"/>
+          </a:fillRef>
+          <a:effectRef idx="2">
+            <a:schemeClr val="accent1"/>
+          </a:effectRef>
+          <a:fontRef idx="minor">
+            <a:schemeClr val="lt1"/>
+          </a:fontRef>
+        </p:style>
+        <p:txBody>
+          <a:bodyPr rtlCol="0" anchor="ctr"/>
+          <a:lstStyle/>
+          <a:p>
+            <a:pPr algn="ctr"/>
+          </a:p>
+        </p:txBody>
+      </p:sp>
+      <p:sp>
+        <p:nvSpPr>
+          <p:cNvPr id="9" name="TextBox 8"/>
+          <p:cNvSpPr txBox="1"/>
+          <p:nvPr/>
+        </p:nvSpPr>
+        <p:spPr>
+          <a:xfrm>
+            <a:off x="2651760" y="1417320"/>
+            <a:ext cx="2011680" cy="548640"/>
+          </a:xfrm>
+          <a:prstGeom prst="rect">
+            <a:avLst/>
+          </a:prstGeom>
+          <a:noFill/>
+        </p:spPr>
+        <p:txBody>
+          <a:bodyPr wrap="square">
+            <a:spAutoFit/>
+          </a:bodyPr>
+          <a:lstStyle/>
+          <a:p>
+            <a:pPr algn="ctr">
+              <a:defRPr sz="3200" b="1">
+                <a:solidFill>
+                  <a:srgbClr val="FFFFFF"/>
+                </a:solidFill>
+                <a:latin typeface="Calibri"/>
+              </a:defRPr>
+            </a:pPr>
+            <a:r>
+              <a:t>76,549</a:t>
+            </a:r>
+          </a:p>
+        </p:txBody>
+      </p:sp>
+      <p:sp>
+        <p:nvSpPr>
+          <p:cNvPr id="10" name="TextBox 9"/>
+          <p:cNvSpPr txBox="1"/>
+          <p:nvPr/>
+        </p:nvSpPr>
+        <p:spPr>
+          <a:xfrm>
+            <a:off x="2651760" y="2011680"/>
+            <a:ext cx="2011680" cy="548640"/>
+          </a:xfrm>
+          <a:prstGeom prst="rect">
+            <a:avLst/>
+          </a:prstGeom>
+          <a:noFill/>
+        </p:spPr>
+        <p:txBody>
+          <a:bodyPr wrap="square">
+            <a:spAutoFit/>
+          </a:bodyPr>
+          <a:lstStyle/>
+          <a:p>
+            <a:pPr algn="ctr">
+              <a:defRPr sz="1300" b="0">
+                <a:solidFill>
+                  <a:srgbClr val="BBDEFB"/>
+                </a:solidFill>
+                <a:latin typeface="Calibri"/>
+              </a:defRPr>
+            </a:pPr>
+            <a:r>
+              <a:t>Classified</a:t>
+            </a:r>
+            <a:br/>
+            <a:r>
+              <a:t>(97.0%)</a:t>
+            </a:r>
+          </a:p>
+        </p:txBody>
+      </p:sp>
+      <p:sp>
+        <p:nvSpPr>
+          <p:cNvPr id="11" name="Rounded Rectangle 10"/>
+          <p:cNvSpPr/>
+          <p:nvPr/>
+        </p:nvSpPr>
+        <p:spPr>
+          <a:xfrm>
+            <a:off x="4937760" y="1280160"/>
+            <a:ext cx="2011680" cy="1371600"/>
+          </a:xfrm>
+          <a:prstGeom prst="roundRect">
+            <a:avLst/>
+          </a:prstGeom>
+          <a:solidFill>
+            <a:srgbClr val="0D47A1"/>
+          </a:solidFill>
+          <a:ln w="25400">
+            <a:solidFill>
+              <a:srgbClr val="1E88E5"/>
+            </a:solidFill>
+          </a:ln>
+        </p:spPr>
+        <p:style>
+          <a:lnRef idx="1">
+            <a:schemeClr val="accent1"/>
+          </a:lnRef>
+          <a:fillRef idx="3">
+            <a:schemeClr val="accent1"/>
+          </a:fillRef>
+          <a:effectRef idx="2">
+            <a:schemeClr val="accent1"/>
+          </a:effectRef>
+          <a:fontRef idx="minor">
+            <a:schemeClr val="lt1"/>
+          </a:fontRef>
+        </p:style>
+        <p:txBody>
+          <a:bodyPr rtlCol="0" anchor="ctr"/>
+          <a:lstStyle/>
+          <a:p>
+            <a:pPr algn="ctr"/>
+          </a:p>
+        </p:txBody>
+      </p:sp>
+      <p:sp>
+        <p:nvSpPr>
+          <p:cNvPr id="12" name="TextBox 11"/>
+          <p:cNvSpPr txBox="1"/>
+          <p:nvPr/>
+        </p:nvSpPr>
+        <p:spPr>
+          <a:xfrm>
+            <a:off x="4937760" y="1417320"/>
+            <a:ext cx="2011680" cy="548640"/>
+          </a:xfrm>
+          <a:prstGeom prst="rect">
+            <a:avLst/>
+          </a:prstGeom>
+          <a:noFill/>
+        </p:spPr>
+        <p:txBody>
+          <a:bodyPr wrap="square">
+            <a:spAutoFit/>
+          </a:bodyPr>
+          <a:lstStyle/>
+          <a:p>
+            <a:pPr algn="ctr">
+              <a:defRPr sz="3200" b="1">
+                <a:solidFill>
+                  <a:srgbClr val="FFFFFF"/>
+                </a:solidFill>
+                <a:latin typeface="Calibri"/>
+              </a:defRPr>
+            </a:pPr>
+            <a:r>
+              <a:t>33,143</a:t>
+            </a:r>
+          </a:p>
+        </p:txBody>
+      </p:sp>
+      <p:sp>
+        <p:nvSpPr>
+          <p:cNvPr id="13" name="TextBox 12"/>
+          <p:cNvSpPr txBox="1"/>
+          <p:nvPr/>
+        </p:nvSpPr>
+        <p:spPr>
+          <a:xfrm>
+            <a:off x="4937760" y="2011680"/>
+            <a:ext cx="2011680" cy="548640"/>
+          </a:xfrm>
+          <a:prstGeom prst="rect">
+            <a:avLst/>
+          </a:prstGeom>
+          <a:noFill/>
+        </p:spPr>
+        <p:txBody>
+          <a:bodyPr wrap="square">
+            <a:spAutoFit/>
+          </a:bodyPr>
+          <a:lstStyle/>
+          <a:p>
+            <a:pPr algn="ctr">
+              <a:defRPr sz="1300" b="0">
+                <a:solidFill>
+                  <a:srgbClr val="BBDEFB"/>
+                </a:solidFill>
+                <a:latin typeface="Calibri"/>
+              </a:defRPr>
+            </a:pPr>
+            <a:r>
+              <a:t>Unique pLIN</a:t>
+            </a:r>
+            <a:br/>
+            <a:r>
+              <a:t>Codes</a:t>
+            </a:r>
+          </a:p>
+        </p:txBody>
+      </p:sp>
+      <p:sp>
+        <p:nvSpPr>
+          <p:cNvPr id="14" name="Rounded Rectangle 13"/>
+          <p:cNvSpPr/>
+          <p:nvPr/>
+        </p:nvSpPr>
+        <p:spPr>
+          <a:xfrm>
+            <a:off x="7223760" y="1280160"/>
+            <a:ext cx="2011680" cy="1371600"/>
+          </a:xfrm>
+          <a:prstGeom prst="roundRect">
+            <a:avLst/>
+          </a:prstGeom>
+          <a:solidFill>
+            <a:srgbClr val="0D47A1"/>
+          </a:solidFill>
+          <a:ln w="25400">
+            <a:solidFill>
+              <a:srgbClr val="1E88E5"/>
+            </a:solidFill>
+          </a:ln>
+        </p:spPr>
+        <p:style>
+          <a:lnRef idx="1">
+            <a:schemeClr val="accent1"/>
+          </a:lnRef>
+          <a:fillRef idx="3">
+            <a:schemeClr val="accent1"/>
+          </a:fillRef>
+          <a:effectRef idx="2">
+            <a:schemeClr val="accent1"/>
+          </a:effectRef>
+          <a:fontRef idx="minor">
+            <a:schemeClr val="lt1"/>
+          </a:fontRef>
+        </p:style>
+        <p:txBody>
+          <a:bodyPr rtlCol="0" anchor="ctr"/>
+          <a:lstStyle/>
+          <a:p>
+            <a:pPr algn="ctr"/>
+          </a:p>
+        </p:txBody>
+      </p:sp>
+      <p:sp>
+        <p:nvSpPr>
+          <p:cNvPr id="15" name="TextBox 14"/>
+          <p:cNvSpPr txBox="1"/>
+          <p:nvPr/>
+        </p:nvSpPr>
+        <p:spPr>
+          <a:xfrm>
+            <a:off x="7223760" y="1417320"/>
+            <a:ext cx="2011680" cy="548640"/>
+          </a:xfrm>
+          <a:prstGeom prst="rect">
+            <a:avLst/>
+          </a:prstGeom>
+          <a:noFill/>
+        </p:spPr>
+        <p:txBody>
+          <a:bodyPr wrap="square">
+            <a:spAutoFit/>
+          </a:bodyPr>
+          <a:lstStyle/>
+          <a:p>
+            <a:pPr algn="ctr">
+              <a:defRPr sz="3200" b="1">
+                <a:solidFill>
+                  <a:srgbClr val="FFFFFF"/>
+                </a:solidFill>
+                <a:latin typeface="Calibri"/>
+              </a:defRPr>
+            </a:pPr>
+            <a:r>
+              <a:t>20</a:t>
+            </a:r>
+          </a:p>
+        </p:txBody>
+      </p:sp>
+      <p:sp>
+        <p:nvSpPr>
+          <p:cNvPr id="16" name="TextBox 15"/>
+          <p:cNvSpPr txBox="1"/>
+          <p:nvPr/>
+        </p:nvSpPr>
+        <p:spPr>
+          <a:xfrm>
+            <a:off x="7223760" y="2011680"/>
+            <a:ext cx="2011680" cy="548640"/>
+          </a:xfrm>
+          <a:prstGeom prst="rect">
+            <a:avLst/>
+          </a:prstGeom>
+          <a:noFill/>
+        </p:spPr>
+        <p:txBody>
+          <a:bodyPr wrap="square">
+            <a:spAutoFit/>
+          </a:bodyPr>
+          <a:lstStyle/>
+          <a:p>
+            <a:pPr algn="ctr">
+              <a:defRPr sz="1300" b="0">
+                <a:solidFill>
+                  <a:srgbClr val="BBDEFB"/>
+                </a:solidFill>
+                <a:latin typeface="Calibri"/>
+              </a:defRPr>
+            </a:pPr>
+            <a:r>
+              <a:t>Inc Groups</a:t>
+            </a:r>
+            <a:br/>
+            <a:r>
+              <a:t>Detected</a:t>
+            </a:r>
+          </a:p>
+        </p:txBody>
+      </p:sp>
+      <p:sp>
+        <p:nvSpPr>
+          <p:cNvPr id="17" name="Rounded Rectangle 16"/>
+          <p:cNvSpPr/>
+          <p:nvPr/>
+        </p:nvSpPr>
+        <p:spPr>
+          <a:xfrm>
+            <a:off x="9509760" y="1280160"/>
+            <a:ext cx="2011680" cy="1371600"/>
+          </a:xfrm>
+          <a:prstGeom prst="roundRect">
+            <a:avLst/>
+          </a:prstGeom>
+          <a:solidFill>
+            <a:srgbClr val="0D47A1"/>
+          </a:solidFill>
+          <a:ln w="25400">
+            <a:solidFill>
+              <a:srgbClr val="1E88E5"/>
+            </a:solidFill>
+          </a:ln>
+        </p:spPr>
+        <p:style>
+          <a:lnRef idx="1">
+            <a:schemeClr val="accent1"/>
+          </a:lnRef>
+          <a:fillRef idx="3">
+            <a:schemeClr val="accent1"/>
+          </a:fillRef>
+          <a:effectRef idx="2">
+            <a:schemeClr val="accent1"/>
+          </a:effectRef>
+          <a:fontRef idx="minor">
+            <a:schemeClr val="lt1"/>
+          </a:fontRef>
+        </p:style>
+        <p:txBody>
+          <a:bodyPr rtlCol="0" anchor="ctr"/>
+          <a:lstStyle/>
+          <a:p>
+            <a:pPr algn="ctr"/>
+          </a:p>
+        </p:txBody>
+      </p:sp>
+      <p:sp>
+        <p:nvSpPr>
+          <p:cNvPr id="18" name="TextBox 17"/>
+          <p:cNvSpPr txBox="1"/>
+          <p:nvPr/>
+        </p:nvSpPr>
+        <p:spPr>
+          <a:xfrm>
+            <a:off x="9509760" y="1417320"/>
+            <a:ext cx="2011680" cy="548640"/>
+          </a:xfrm>
+          <a:prstGeom prst="rect">
+            <a:avLst/>
+          </a:prstGeom>
+          <a:noFill/>
+        </p:spPr>
+        <p:txBody>
+          <a:bodyPr wrap="square">
+            <a:spAutoFit/>
+          </a:bodyPr>
+          <a:lstStyle/>
+          <a:p>
+            <a:pPr algn="ctr">
+              <a:defRPr sz="3200" b="1">
+                <a:solidFill>
+                  <a:srgbClr val="FFFFFF"/>
+                </a:solidFill>
+                <a:latin typeface="Calibri"/>
+              </a:defRPr>
+            </a:pPr>
+            <a:r>
+              <a:t>2,353</a:t>
+            </a:r>
+          </a:p>
+        </p:txBody>
+      </p:sp>
+      <p:sp>
+        <p:nvSpPr>
+          <p:cNvPr id="19" name="TextBox 18"/>
+          <p:cNvSpPr txBox="1"/>
+          <p:nvPr/>
+        </p:nvSpPr>
+        <p:spPr>
+          <a:xfrm>
+            <a:off x="9509760" y="2011680"/>
+            <a:ext cx="2011680" cy="548640"/>
+          </a:xfrm>
+          <a:prstGeom prst="rect">
+            <a:avLst/>
+          </a:prstGeom>
+          <a:noFill/>
+        </p:spPr>
+        <p:txBody>
+          <a:bodyPr wrap="square">
+            <a:spAutoFit/>
+          </a:bodyPr>
+          <a:lstStyle/>
+          <a:p>
+            <a:pPr algn="ctr">
+              <a:defRPr sz="1300" b="0">
+                <a:solidFill>
+                  <a:srgbClr val="BBDEFB"/>
+                </a:solidFill>
+                <a:latin typeface="Calibri"/>
+              </a:defRPr>
+            </a:pPr>
+            <a:r>
+              <a:t>Unknown/</a:t>
+            </a:r>
+            <a:br/>
+            <a:r>
+              <a:t>Novel (3.0%)</a:t>
+            </a:r>
+          </a:p>
+        </p:txBody>
+      </p:sp>
+      <p:sp>
+        <p:nvSpPr>
+          <p:cNvPr id="20" name="TextBox 19"/>
+          <p:cNvSpPr txBox="1"/>
+          <p:nvPr/>
+        </p:nvSpPr>
+        <p:spPr>
+          <a:xfrm>
+            <a:off x="365760" y="2834640"/>
+            <a:ext cx="10972800" cy="365760"/>
+          </a:xfrm>
+          <a:prstGeom prst="rect">
+            <a:avLst/>
+          </a:prstGeom>
+          <a:noFill/>
+        </p:spPr>
+        <p:txBody>
+          <a:bodyPr wrap="square">
+            <a:spAutoFit/>
+          </a:bodyPr>
+          <a:lstStyle/>
+          <a:p>
+            <a:pPr algn="l">
+              <a:defRPr sz="1400" b="1">
+                <a:solidFill>
+                  <a:srgbClr val="0D47A1"/>
+                </a:solidFill>
+                <a:latin typeface="Calibri"/>
+              </a:defRPr>
+            </a:pPr>
+            <a:r>
+              <a:t>Hierarchical Clustering Resolution</a:t>
+            </a:r>
+          </a:p>
+        </p:txBody>
+      </p:sp>
+      <p:sp>
+        <p:nvSpPr>
+          <p:cNvPr id="21" name="Rounded Rectangle 20"/>
+          <p:cNvSpPr/>
+          <p:nvPr/>
+        </p:nvSpPr>
+        <p:spPr>
+          <a:xfrm>
+            <a:off x="365760" y="3200400"/>
+            <a:ext cx="1737360" cy="1188720"/>
+          </a:xfrm>
+          <a:prstGeom prst="roundRect">
+            <a:avLst/>
+          </a:prstGeom>
+          <a:solidFill>
+            <a:srgbClr val="E53935"/>
+          </a:solidFill>
+          <a:ln w="25400">
+            <a:solidFill>
+              <a:srgbClr val="E53935"/>
+            </a:solidFill>
+          </a:ln>
+        </p:spPr>
+        <p:style>
+          <a:lnRef idx="1">
+            <a:schemeClr val="accent1"/>
+          </a:lnRef>
+          <a:fillRef idx="3">
+            <a:schemeClr val="accent1"/>
+          </a:fillRef>
+          <a:effectRef idx="2">
+            <a:schemeClr val="accent1"/>
+          </a:effectRef>
+          <a:fontRef idx="minor">
+            <a:schemeClr val="lt1"/>
+          </a:fontRef>
+        </p:style>
+        <p:txBody>
+          <a:bodyPr rtlCol="0" anchor="ctr"/>
+          <a:lstStyle/>
+          <a:p>
+            <a:pPr algn="ctr"/>
+          </a:p>
+        </p:txBody>
+      </p:sp>
+      <p:sp>
+        <p:nvSpPr>
+          <p:cNvPr id="22" name="TextBox 21"/>
+          <p:cNvSpPr txBox="1"/>
+          <p:nvPr/>
+        </p:nvSpPr>
+        <p:spPr>
+          <a:xfrm>
+            <a:off x="365760" y="3246120"/>
+            <a:ext cx="1737360" cy="320040"/>
+          </a:xfrm>
+          <a:prstGeom prst="rect">
+            <a:avLst/>
+          </a:prstGeom>
+          <a:noFill/>
+        </p:spPr>
+        <p:txBody>
+          <a:bodyPr wrap="square">
+            <a:spAutoFit/>
+          </a:bodyPr>
+          <a:lstStyle/>
+          <a:p>
+            <a:pPr algn="ctr">
+              <a:defRPr sz="1000" b="1">
+                <a:solidFill>
+                  <a:srgbClr val="FFFFFF"/>
+                </a:solidFill>
+                <a:latin typeface="Calibri"/>
+              </a:defRPr>
+            </a:pPr>
+            <a:r>
+              <a:t>L1 (Family)</a:t>
+            </a:r>
+          </a:p>
+        </p:txBody>
+      </p:sp>
+      <p:sp>
+        <p:nvSpPr>
+          <p:cNvPr id="23" name="TextBox 22"/>
+          <p:cNvSpPr txBox="1"/>
+          <p:nvPr/>
+        </p:nvSpPr>
+        <p:spPr>
+          <a:xfrm>
+            <a:off x="365760" y="3520440"/>
+            <a:ext cx="1737360" cy="457200"/>
+          </a:xfrm>
+          <a:prstGeom prst="rect">
+            <a:avLst/>
+          </a:prstGeom>
+          <a:noFill/>
+        </p:spPr>
+        <p:txBody>
+          <a:bodyPr wrap="square">
+            <a:spAutoFit/>
+          </a:bodyPr>
+          <a:lstStyle/>
+          <a:p>
+            <a:pPr algn="ctr">
+              <a:defRPr sz="2200" b="1">
+                <a:solidFill>
+                  <a:srgbClr val="FFFFFF"/>
+                </a:solidFill>
+                <a:latin typeface="Calibri"/>
+              </a:defRPr>
+            </a:pPr>
+            <a:r>
+              <a:t>33</a:t>
+            </a:r>
+          </a:p>
+        </p:txBody>
+      </p:sp>
+      <p:sp>
+        <p:nvSpPr>
+          <p:cNvPr id="24" name="TextBox 23"/>
+          <p:cNvSpPr txBox="1"/>
+          <p:nvPr/>
+        </p:nvSpPr>
+        <p:spPr>
+          <a:xfrm>
+            <a:off x="365760" y="4023360"/>
+            <a:ext cx="1737360" cy="274320"/>
+          </a:xfrm>
+          <a:prstGeom prst="rect">
+            <a:avLst/>
+          </a:prstGeom>
+          <a:noFill/>
+        </p:spPr>
+        <p:txBody>
+          <a:bodyPr wrap="square">
+            <a:spAutoFit/>
+          </a:bodyPr>
+          <a:lstStyle/>
+          <a:p>
+            <a:pPr algn="ctr">
+              <a:defRPr sz="900" b="0">
+                <a:solidFill>
+                  <a:srgbClr val="FFFFFF"/>
+                </a:solidFill>
+                <a:latin typeface="Calibri"/>
+              </a:defRPr>
+            </a:pPr>
+            <a:r>
+              <a:t>d ≤ 0.150</a:t>
+            </a:r>
+          </a:p>
+        </p:txBody>
+      </p:sp>
+      <p:sp>
+        <p:nvSpPr>
+          <p:cNvPr id="25" name="Rounded Rectangle 24"/>
+          <p:cNvSpPr/>
+          <p:nvPr/>
+        </p:nvSpPr>
+        <p:spPr>
+          <a:xfrm>
+            <a:off x="2286000" y="3200400"/>
+            <a:ext cx="1737360" cy="1188720"/>
+          </a:xfrm>
+          <a:prstGeom prst="roundRect">
+            <a:avLst/>
+          </a:prstGeom>
+          <a:solidFill>
+            <a:srgbClr val="FB8C00"/>
+          </a:solidFill>
+          <a:ln w="25400">
+            <a:solidFill>
+              <a:srgbClr val="FB8C00"/>
+            </a:solidFill>
+          </a:ln>
+        </p:spPr>
+        <p:style>
+          <a:lnRef idx="1">
+            <a:schemeClr val="accent1"/>
+          </a:lnRef>
+          <a:fillRef idx="3">
+            <a:schemeClr val="accent1"/>
+          </a:fillRef>
+          <a:effectRef idx="2">
+            <a:schemeClr val="accent1"/>
+          </a:effectRef>
+          <a:fontRef idx="minor">
+            <a:schemeClr val="lt1"/>
+          </a:fontRef>
+        </p:style>
+        <p:txBody>
+          <a:bodyPr rtlCol="0" anchor="ctr"/>
+          <a:lstStyle/>
+          <a:p>
+            <a:pPr algn="ctr"/>
+          </a:p>
+        </p:txBody>
+      </p:sp>
+      <p:sp>
+        <p:nvSpPr>
+          <p:cNvPr id="26" name="TextBox 25"/>
+          <p:cNvSpPr txBox="1"/>
+          <p:nvPr/>
+        </p:nvSpPr>
+        <p:spPr>
+          <a:xfrm>
+            <a:off x="2286000" y="3246120"/>
+            <a:ext cx="1737360" cy="320040"/>
+          </a:xfrm>
+          <a:prstGeom prst="rect">
+            <a:avLst/>
+          </a:prstGeom>
+          <a:noFill/>
+        </p:spPr>
+        <p:txBody>
+          <a:bodyPr wrap="square">
+            <a:spAutoFit/>
+          </a:bodyPr>
+          <a:lstStyle/>
+          <a:p>
+            <a:pPr algn="ctr">
+              <a:defRPr sz="1000" b="1">
+                <a:solidFill>
+                  <a:srgbClr val="FFFFFF"/>
+                </a:solidFill>
+                <a:latin typeface="Calibri"/>
+              </a:defRPr>
+            </a:pPr>
+            <a:r>
+              <a:t>L2 (Subfamily)</a:t>
+            </a:r>
+          </a:p>
+        </p:txBody>
+      </p:sp>
+      <p:sp>
+        <p:nvSpPr>
+          <p:cNvPr id="27" name="TextBox 26"/>
+          <p:cNvSpPr txBox="1"/>
+          <p:nvPr/>
+        </p:nvSpPr>
+        <p:spPr>
+          <a:xfrm>
+            <a:off x="2286000" y="3520440"/>
+            <a:ext cx="1737360" cy="457200"/>
+          </a:xfrm>
+          <a:prstGeom prst="rect">
+            <a:avLst/>
+          </a:prstGeom>
+          <a:noFill/>
+        </p:spPr>
+        <p:txBody>
+          <a:bodyPr wrap="square">
+            <a:spAutoFit/>
+          </a:bodyPr>
+          <a:lstStyle/>
+          <a:p>
+            <a:pPr algn="ctr">
+              <a:defRPr sz="2200" b="1">
+                <a:solidFill>
+                  <a:srgbClr val="FFFFFF"/>
+                </a:solidFill>
+                <a:latin typeface="Calibri"/>
+              </a:defRPr>
+            </a:pPr>
+            <a:r>
+              <a:t>86</a:t>
+            </a:r>
+          </a:p>
+        </p:txBody>
+      </p:sp>
+      <p:sp>
+        <p:nvSpPr>
+          <p:cNvPr id="28" name="TextBox 27"/>
+          <p:cNvSpPr txBox="1"/>
+          <p:nvPr/>
+        </p:nvSpPr>
+        <p:spPr>
+          <a:xfrm>
+            <a:off x="2286000" y="4023360"/>
+            <a:ext cx="1737360" cy="274320"/>
+          </a:xfrm>
+          <a:prstGeom prst="rect">
+            <a:avLst/>
+          </a:prstGeom>
+          <a:noFill/>
+        </p:spPr>
+        <p:txBody>
+          <a:bodyPr wrap="square">
+            <a:spAutoFit/>
+          </a:bodyPr>
+          <a:lstStyle/>
+          <a:p>
+            <a:pPr algn="ctr">
+              <a:defRPr sz="900" b="0">
+                <a:solidFill>
+                  <a:srgbClr val="FFFFFF"/>
+                </a:solidFill>
+                <a:latin typeface="Calibri"/>
+              </a:defRPr>
+            </a:pPr>
+            <a:r>
+              <a:t>d ≤ 0.100</a:t>
+            </a:r>
+          </a:p>
+        </p:txBody>
+      </p:sp>
+      <p:sp>
+        <p:nvSpPr>
+          <p:cNvPr id="29" name="Rounded Rectangle 28"/>
+          <p:cNvSpPr/>
+          <p:nvPr/>
+        </p:nvSpPr>
+        <p:spPr>
+          <a:xfrm>
+            <a:off x="4206240" y="3200400"/>
+            <a:ext cx="1737360" cy="1188720"/>
+          </a:xfrm>
+          <a:prstGeom prst="roundRect">
+            <a:avLst/>
+          </a:prstGeom>
+          <a:solidFill>
+            <a:srgbClr val="FDD835"/>
+          </a:solidFill>
+          <a:ln w="25400">
+            <a:solidFill>
+              <a:srgbClr val="FDD835"/>
+            </a:solidFill>
+          </a:ln>
+        </p:spPr>
+        <p:style>
+          <a:lnRef idx="1">
+            <a:schemeClr val="accent1"/>
+          </a:lnRef>
+          <a:fillRef idx="3">
+            <a:schemeClr val="accent1"/>
+          </a:fillRef>
+          <a:effectRef idx="2">
+            <a:schemeClr val="accent1"/>
+          </a:effectRef>
+          <a:fontRef idx="minor">
+            <a:schemeClr val="lt1"/>
+          </a:fontRef>
+        </p:style>
+        <p:txBody>
+          <a:bodyPr rtlCol="0" anchor="ctr"/>
+          <a:lstStyle/>
+          <a:p>
+            <a:pPr algn="ctr"/>
+          </a:p>
+        </p:txBody>
+      </p:sp>
+      <p:sp>
+        <p:nvSpPr>
+          <p:cNvPr id="30" name="TextBox 29"/>
+          <p:cNvSpPr txBox="1"/>
+          <p:nvPr/>
+        </p:nvSpPr>
+        <p:spPr>
+          <a:xfrm>
+            <a:off x="4206240" y="3246120"/>
+            <a:ext cx="1737360" cy="320040"/>
+          </a:xfrm>
+          <a:prstGeom prst="rect">
+            <a:avLst/>
+          </a:prstGeom>
+          <a:noFill/>
+        </p:spPr>
+        <p:txBody>
+          <a:bodyPr wrap="square">
+            <a:spAutoFit/>
+          </a:bodyPr>
+          <a:lstStyle/>
+          <a:p>
+            <a:pPr algn="ctr">
+              <a:defRPr sz="1000" b="1">
+                <a:solidFill>
+                  <a:srgbClr val="FFFFFF"/>
+                </a:solidFill>
+                <a:latin typeface="Calibri"/>
+              </a:defRPr>
+            </a:pPr>
+            <a:r>
+              <a:t>L3 (Cluster)</a:t>
+            </a:r>
+          </a:p>
+        </p:txBody>
+      </p:sp>
+      <p:sp>
+        <p:nvSpPr>
+          <p:cNvPr id="31" name="TextBox 30"/>
+          <p:cNvSpPr txBox="1"/>
+          <p:nvPr/>
+        </p:nvSpPr>
+        <p:spPr>
+          <a:xfrm>
+            <a:off x="4206240" y="3520440"/>
+            <a:ext cx="1737360" cy="457200"/>
+          </a:xfrm>
+          <a:prstGeom prst="rect">
+            <a:avLst/>
+          </a:prstGeom>
+          <a:noFill/>
+        </p:spPr>
+        <p:txBody>
+          <a:bodyPr wrap="square">
+            <a:spAutoFit/>
+          </a:bodyPr>
+          <a:lstStyle/>
+          <a:p>
+            <a:pPr algn="ctr">
+              <a:defRPr sz="2200" b="1">
+                <a:solidFill>
+                  <a:srgbClr val="FFFFFF"/>
+                </a:solidFill>
+                <a:latin typeface="Calibri"/>
+              </a:defRPr>
+            </a:pPr>
+            <a:r>
+              <a:t>447</a:t>
+            </a:r>
+          </a:p>
+        </p:txBody>
+      </p:sp>
+      <p:sp>
+        <p:nvSpPr>
+          <p:cNvPr id="32" name="TextBox 31"/>
+          <p:cNvSpPr txBox="1"/>
+          <p:nvPr/>
+        </p:nvSpPr>
+        <p:spPr>
+          <a:xfrm>
+            <a:off x="4206240" y="4023360"/>
+            <a:ext cx="1737360" cy="274320"/>
+          </a:xfrm>
+          <a:prstGeom prst="rect">
+            <a:avLst/>
+          </a:prstGeom>
+          <a:noFill/>
+        </p:spPr>
+        <p:txBody>
+          <a:bodyPr wrap="square">
+            <a:spAutoFit/>
+          </a:bodyPr>
+          <a:lstStyle/>
+          <a:p>
+            <a:pPr algn="ctr">
+              <a:defRPr sz="900" b="0">
+                <a:solidFill>
+                  <a:srgbClr val="FFFFFF"/>
+                </a:solidFill>
+                <a:latin typeface="Calibri"/>
+              </a:defRPr>
+            </a:pPr>
+            <a:r>
+              <a:t>d ≤ 0.050</a:t>
+            </a:r>
+          </a:p>
+        </p:txBody>
+      </p:sp>
+      <p:sp>
+        <p:nvSpPr>
+          <p:cNvPr id="33" name="Rounded Rectangle 32"/>
+          <p:cNvSpPr/>
+          <p:nvPr/>
+        </p:nvSpPr>
+        <p:spPr>
+          <a:xfrm>
+            <a:off x="6126480" y="3200400"/>
+            <a:ext cx="1737360" cy="1188720"/>
+          </a:xfrm>
+          <a:prstGeom prst="roundRect">
+            <a:avLst/>
+          </a:prstGeom>
+          <a:solidFill>
+            <a:srgbClr val="43A047"/>
+          </a:solidFill>
+          <a:ln w="25400">
+            <a:solidFill>
+              <a:srgbClr val="43A047"/>
+            </a:solidFill>
+          </a:ln>
+        </p:spPr>
+        <p:style>
+          <a:lnRef idx="1">
+            <a:schemeClr val="accent1"/>
+          </a:lnRef>
+          <a:fillRef idx="3">
+            <a:schemeClr val="accent1"/>
+          </a:fillRef>
+          <a:effectRef idx="2">
+            <a:schemeClr val="accent1"/>
+          </a:effectRef>
+          <a:fontRef idx="minor">
+            <a:schemeClr val="lt1"/>
+          </a:fontRef>
+        </p:style>
+        <p:txBody>
+          <a:bodyPr rtlCol="0" anchor="ctr"/>
+          <a:lstStyle/>
+          <a:p>
+            <a:pPr algn="ctr"/>
+          </a:p>
+        </p:txBody>
+      </p:sp>
+      <p:sp>
+        <p:nvSpPr>
+          <p:cNvPr id="34" name="TextBox 33"/>
+          <p:cNvSpPr txBox="1"/>
+          <p:nvPr/>
+        </p:nvSpPr>
+        <p:spPr>
+          <a:xfrm>
+            <a:off x="6126480" y="3246120"/>
+            <a:ext cx="1737360" cy="320040"/>
+          </a:xfrm>
+          <a:prstGeom prst="rect">
+            <a:avLst/>
+          </a:prstGeom>
+          <a:noFill/>
+        </p:spPr>
+        <p:txBody>
+          <a:bodyPr wrap="square">
+            <a:spAutoFit/>
+          </a:bodyPr>
+          <a:lstStyle/>
+          <a:p>
+            <a:pPr algn="ctr">
+              <a:defRPr sz="1000" b="1">
+                <a:solidFill>
+                  <a:srgbClr val="FFFFFF"/>
+                </a:solidFill>
+                <a:latin typeface="Calibri"/>
+              </a:defRPr>
+            </a:pPr>
+            <a:r>
+              <a:t>L4 (Subcluster)</a:t>
+            </a:r>
+          </a:p>
+        </p:txBody>
+      </p:sp>
+      <p:sp>
+        <p:nvSpPr>
+          <p:cNvPr id="35" name="TextBox 34"/>
+          <p:cNvSpPr txBox="1"/>
+          <p:nvPr/>
+        </p:nvSpPr>
+        <p:spPr>
+          <a:xfrm>
+            <a:off x="6126480" y="3520440"/>
+            <a:ext cx="1737360" cy="457200"/>
+          </a:xfrm>
+          <a:prstGeom prst="rect">
+            <a:avLst/>
+          </a:prstGeom>
+          <a:noFill/>
+        </p:spPr>
+        <p:txBody>
+          <a:bodyPr wrap="square">
+            <a:spAutoFit/>
+          </a:bodyPr>
+          <a:lstStyle/>
+          <a:p>
+            <a:pPr algn="ctr">
+              <a:defRPr sz="2200" b="1">
+                <a:solidFill>
+                  <a:srgbClr val="FFFFFF"/>
+                </a:solidFill>
+                <a:latin typeface="Calibri"/>
+              </a:defRPr>
+            </a:pPr>
+            <a:r>
+              <a:t>2,772</a:t>
+            </a:r>
+          </a:p>
+        </p:txBody>
+      </p:sp>
+      <p:sp>
+        <p:nvSpPr>
+          <p:cNvPr id="36" name="TextBox 35"/>
+          <p:cNvSpPr txBox="1"/>
+          <p:nvPr/>
+        </p:nvSpPr>
+        <p:spPr>
+          <a:xfrm>
+            <a:off x="6126480" y="4023360"/>
+            <a:ext cx="1737360" cy="274320"/>
+          </a:xfrm>
+          <a:prstGeom prst="rect">
+            <a:avLst/>
+          </a:prstGeom>
+          <a:noFill/>
+        </p:spPr>
+        <p:txBody>
+          <a:bodyPr wrap="square">
+            <a:spAutoFit/>
+          </a:bodyPr>
+          <a:lstStyle/>
+          <a:p>
+            <a:pPr algn="ctr">
+              <a:defRPr sz="900" b="0">
+                <a:solidFill>
+                  <a:srgbClr val="FFFFFF"/>
+                </a:solidFill>
+                <a:latin typeface="Calibri"/>
+              </a:defRPr>
+            </a:pPr>
+            <a:r>
+              <a:t>d ≤ 0.020</a:t>
+            </a:r>
+          </a:p>
+        </p:txBody>
+      </p:sp>
+      <p:sp>
+        <p:nvSpPr>
+          <p:cNvPr id="37" name="Rounded Rectangle 36"/>
+          <p:cNvSpPr/>
+          <p:nvPr/>
+        </p:nvSpPr>
+        <p:spPr>
+          <a:xfrm>
+            <a:off x="8046720" y="3200400"/>
+            <a:ext cx="1737360" cy="1188720"/>
+          </a:xfrm>
+          <a:prstGeom prst="roundRect">
+            <a:avLst/>
+          </a:prstGeom>
+          <a:solidFill>
+            <a:srgbClr val="1E88E5"/>
+          </a:solidFill>
+          <a:ln w="25400">
+            <a:solidFill>
+              <a:srgbClr val="1E88E5"/>
+            </a:solidFill>
+          </a:ln>
+        </p:spPr>
+        <p:style>
+          <a:lnRef idx="1">
+            <a:schemeClr val="accent1"/>
+          </a:lnRef>
+          <a:fillRef idx="3">
+            <a:schemeClr val="accent1"/>
+          </a:fillRef>
+          <a:effectRef idx="2">
+            <a:schemeClr val="accent1"/>
+          </a:effectRef>
+          <a:fontRef idx="minor">
+            <a:schemeClr val="lt1"/>
+          </a:fontRef>
+        </p:style>
+        <p:txBody>
+          <a:bodyPr rtlCol="0" anchor="ctr"/>
+          <a:lstStyle/>
+          <a:p>
+            <a:pPr algn="ctr"/>
+          </a:p>
+        </p:txBody>
+      </p:sp>
+      <p:sp>
+        <p:nvSpPr>
+          <p:cNvPr id="38" name="TextBox 37"/>
+          <p:cNvSpPr txBox="1"/>
+          <p:nvPr/>
+        </p:nvSpPr>
+        <p:spPr>
+          <a:xfrm>
+            <a:off x="8046720" y="3246120"/>
+            <a:ext cx="1737360" cy="320040"/>
+          </a:xfrm>
+          <a:prstGeom prst="rect">
+            <a:avLst/>
+          </a:prstGeom>
+          <a:noFill/>
+        </p:spPr>
+        <p:txBody>
+          <a:bodyPr wrap="square">
+            <a:spAutoFit/>
+          </a:bodyPr>
+          <a:lstStyle/>
+          <a:p>
+            <a:pPr algn="ctr">
+              <a:defRPr sz="1000" b="1">
+                <a:solidFill>
+                  <a:srgbClr val="FFFFFF"/>
+                </a:solidFill>
+                <a:latin typeface="Calibri"/>
+              </a:defRPr>
+            </a:pPr>
+            <a:r>
+              <a:t>L5 (Clone)</a:t>
+            </a:r>
+          </a:p>
+        </p:txBody>
+      </p:sp>
+      <p:sp>
+        <p:nvSpPr>
+          <p:cNvPr id="39" name="TextBox 38"/>
+          <p:cNvSpPr txBox="1"/>
+          <p:nvPr/>
+        </p:nvSpPr>
+        <p:spPr>
+          <a:xfrm>
+            <a:off x="8046720" y="3520440"/>
+            <a:ext cx="1737360" cy="457200"/>
+          </a:xfrm>
+          <a:prstGeom prst="rect">
+            <a:avLst/>
+          </a:prstGeom>
+          <a:noFill/>
+        </p:spPr>
+        <p:txBody>
+          <a:bodyPr wrap="square">
+            <a:spAutoFit/>
+          </a:bodyPr>
+          <a:lstStyle/>
+          <a:p>
+            <a:pPr algn="ctr">
+              <a:defRPr sz="2200" b="1">
+                <a:solidFill>
+                  <a:srgbClr val="FFFFFF"/>
+                </a:solidFill>
+                <a:latin typeface="Calibri"/>
+              </a:defRPr>
+            </a:pPr>
+            <a:r>
+              <a:t>5,540</a:t>
+            </a:r>
+          </a:p>
+        </p:txBody>
+      </p:sp>
+      <p:sp>
+        <p:nvSpPr>
+          <p:cNvPr id="40" name="TextBox 39"/>
+          <p:cNvSpPr txBox="1"/>
+          <p:nvPr/>
+        </p:nvSpPr>
+        <p:spPr>
+          <a:xfrm>
+            <a:off x="8046720" y="4023360"/>
+            <a:ext cx="1737360" cy="274320"/>
+          </a:xfrm>
+          <a:prstGeom prst="rect">
+            <a:avLst/>
+          </a:prstGeom>
+          <a:noFill/>
+        </p:spPr>
+        <p:txBody>
+          <a:bodyPr wrap="square">
+            <a:spAutoFit/>
+          </a:bodyPr>
+          <a:lstStyle/>
+          <a:p>
+            <a:pPr algn="ctr">
+              <a:defRPr sz="900" b="0">
+                <a:solidFill>
+                  <a:srgbClr val="FFFFFF"/>
+                </a:solidFill>
+                <a:latin typeface="Calibri"/>
+              </a:defRPr>
+            </a:pPr>
+            <a:r>
+              <a:t>d ≤ 0.010</a:t>
+            </a:r>
+          </a:p>
+        </p:txBody>
+      </p:sp>
+      <p:sp>
+        <p:nvSpPr>
+          <p:cNvPr id="41" name="Rounded Rectangle 40"/>
+          <p:cNvSpPr/>
+          <p:nvPr/>
+        </p:nvSpPr>
+        <p:spPr>
+          <a:xfrm>
+            <a:off x="9966960" y="3200400"/>
+            <a:ext cx="1737360" cy="1188720"/>
+          </a:xfrm>
+          <a:prstGeom prst="roundRect">
+            <a:avLst/>
+          </a:prstGeom>
+          <a:solidFill>
+            <a:srgbClr val="8E24AA"/>
+          </a:solidFill>
+          <a:ln w="25400">
+            <a:solidFill>
+              <a:srgbClr val="8E24AA"/>
+            </a:solidFill>
+          </a:ln>
+        </p:spPr>
+        <p:style>
+          <a:lnRef idx="1">
+            <a:schemeClr val="accent1"/>
+          </a:lnRef>
+          <a:fillRef idx="3">
+            <a:schemeClr val="accent1"/>
+          </a:fillRef>
+          <a:effectRef idx="2">
+            <a:schemeClr val="accent1"/>
+          </a:effectRef>
+          <a:fontRef idx="minor">
+            <a:schemeClr val="lt1"/>
+          </a:fontRef>
+        </p:style>
+        <p:txBody>
+          <a:bodyPr rtlCol="0" anchor="ctr"/>
+          <a:lstStyle/>
+          <a:p>
+            <a:pPr algn="ctr"/>
+          </a:p>
+        </p:txBody>
+      </p:sp>
+      <p:sp>
+        <p:nvSpPr>
+          <p:cNvPr id="42" name="TextBox 41"/>
+          <p:cNvSpPr txBox="1"/>
+          <p:nvPr/>
+        </p:nvSpPr>
+        <p:spPr>
+          <a:xfrm>
+            <a:off x="9966960" y="3246120"/>
+            <a:ext cx="1737360" cy="320040"/>
+          </a:xfrm>
+          <a:prstGeom prst="rect">
+            <a:avLst/>
+          </a:prstGeom>
+          <a:noFill/>
+        </p:spPr>
+        <p:txBody>
+          <a:bodyPr wrap="square">
+            <a:spAutoFit/>
+          </a:bodyPr>
+          <a:lstStyle/>
+          <a:p>
+            <a:pPr algn="ctr">
+              <a:defRPr sz="1000" b="1">
+                <a:solidFill>
+                  <a:srgbClr val="FFFFFF"/>
+                </a:solidFill>
+                <a:latin typeface="Calibri"/>
+              </a:defRPr>
+            </a:pPr>
+            <a:r>
+              <a:t>L6 (Strain)</a:t>
+            </a:r>
+          </a:p>
+        </p:txBody>
+      </p:sp>
+      <p:sp>
+        <p:nvSpPr>
+          <p:cNvPr id="43" name="TextBox 42"/>
+          <p:cNvSpPr txBox="1"/>
+          <p:nvPr/>
+        </p:nvSpPr>
+        <p:spPr>
+          <a:xfrm>
+            <a:off x="9966960" y="3520440"/>
+            <a:ext cx="1737360" cy="457200"/>
+          </a:xfrm>
+          <a:prstGeom prst="rect">
+            <a:avLst/>
+          </a:prstGeom>
+          <a:noFill/>
+        </p:spPr>
+        <p:txBody>
+          <a:bodyPr wrap="square">
+            <a:spAutoFit/>
+          </a:bodyPr>
+          <a:lstStyle/>
+          <a:p>
+            <a:pPr algn="ctr">
+              <a:defRPr sz="2200" b="1">
+                <a:solidFill>
+                  <a:srgbClr val="FFFFFF"/>
+                </a:solidFill>
+                <a:latin typeface="Calibri"/>
+              </a:defRPr>
+            </a:pPr>
+            <a:r>
+              <a:t>33,143</a:t>
+            </a:r>
+          </a:p>
+        </p:txBody>
+      </p:sp>
+      <p:sp>
+        <p:nvSpPr>
+          <p:cNvPr id="44" name="TextBox 43"/>
+          <p:cNvSpPr txBox="1"/>
+          <p:nvPr/>
+        </p:nvSpPr>
+        <p:spPr>
+          <a:xfrm>
+            <a:off x="9966960" y="4023360"/>
+            <a:ext cx="1737360" cy="274320"/>
+          </a:xfrm>
+          <a:prstGeom prst="rect">
+            <a:avLst/>
+          </a:prstGeom>
+          <a:noFill/>
+        </p:spPr>
+        <p:txBody>
+          <a:bodyPr wrap="square">
+            <a:spAutoFit/>
+          </a:bodyPr>
+          <a:lstStyle/>
+          <a:p>
+            <a:pPr algn="ctr">
+              <a:defRPr sz="900" b="0">
+                <a:solidFill>
+                  <a:srgbClr val="FFFFFF"/>
+                </a:solidFill>
+                <a:latin typeface="Calibri"/>
+              </a:defRPr>
+            </a:pPr>
+            <a:r>
+              <a:t>d ≤ 0.001</a:t>
+            </a:r>
+          </a:p>
+        </p:txBody>
+      </p:sp>
+      <p:sp>
+        <p:nvSpPr>
+          <p:cNvPr id="45" name="TextBox 44"/>
+          <p:cNvSpPr txBox="1"/>
+          <p:nvPr/>
+        </p:nvSpPr>
+        <p:spPr>
+          <a:xfrm>
+            <a:off x="365760" y="4572000"/>
+            <a:ext cx="10972800" cy="320040"/>
+          </a:xfrm>
+          <a:prstGeom prst="rect">
+            <a:avLst/>
+          </a:prstGeom>
+          <a:noFill/>
+        </p:spPr>
+        <p:txBody>
+          <a:bodyPr wrap="square">
+            <a:spAutoFit/>
+          </a:bodyPr>
+          <a:lstStyle/>
+          <a:p>
+            <a:pPr algn="l">
+              <a:defRPr sz="1300" b="1">
+                <a:solidFill>
+                  <a:srgbClr val="0D47A1"/>
+                </a:solidFill>
+                <a:latin typeface="Calibri"/>
+              </a:defRPr>
+            </a:pPr>
+            <a:r>
+              <a:t>Inc Group Distribution (Top 10)</a:t>
+            </a:r>
+          </a:p>
+        </p:txBody>
+      </p:sp>
+      <p:sp>
+        <p:nvSpPr>
+          <p:cNvPr id="46" name="TextBox 45"/>
+          <p:cNvSpPr txBox="1"/>
+          <p:nvPr/>
+        </p:nvSpPr>
+        <p:spPr>
+          <a:xfrm>
+            <a:off x="457200" y="4892040"/>
+            <a:ext cx="1828800" cy="274320"/>
+          </a:xfrm>
+          <a:prstGeom prst="rect">
+            <a:avLst/>
+          </a:prstGeom>
+          <a:noFill/>
+        </p:spPr>
+        <p:txBody>
+          <a:bodyPr wrap="square">
+            <a:spAutoFit/>
+          </a:bodyPr>
+          <a:lstStyle/>
+          <a:p>
+            <a:pPr algn="l">
+              <a:defRPr sz="1000" b="1">
+                <a:solidFill>
+                  <a:srgbClr val="1E88E5"/>
+                </a:solidFill>
+                <a:latin typeface="Calibri"/>
+              </a:defRPr>
+            </a:pPr>
+            <a:r>
+              <a:t>Inc Type</a:t>
+            </a:r>
+          </a:p>
+        </p:txBody>
+      </p:sp>
+      <p:sp>
+        <p:nvSpPr>
+          <p:cNvPr id="47" name="TextBox 46"/>
+          <p:cNvSpPr txBox="1"/>
+          <p:nvPr/>
+        </p:nvSpPr>
+        <p:spPr>
+          <a:xfrm>
+            <a:off x="2560320" y="4892040"/>
+            <a:ext cx="1828800" cy="274320"/>
+          </a:xfrm>
+          <a:prstGeom prst="rect">
+            <a:avLst/>
+          </a:prstGeom>
+          <a:noFill/>
+        </p:spPr>
+        <p:txBody>
+          <a:bodyPr wrap="square">
+            <a:spAutoFit/>
+          </a:bodyPr>
+          <a:lstStyle/>
+          <a:p>
+            <a:pPr algn="l">
+              <a:defRPr sz="1000" b="1">
+                <a:solidFill>
+                  <a:srgbClr val="1E88E5"/>
+                </a:solidFill>
+                <a:latin typeface="Calibri"/>
+              </a:defRPr>
+            </a:pPr>
+            <a:r>
+              <a:t>Sequences</a:t>
+            </a:r>
+          </a:p>
+        </p:txBody>
+      </p:sp>
+      <p:sp>
+        <p:nvSpPr>
+          <p:cNvPr id="48" name="TextBox 47"/>
+          <p:cNvSpPr txBox="1"/>
+          <p:nvPr/>
+        </p:nvSpPr>
+        <p:spPr>
+          <a:xfrm>
+            <a:off x="4846320" y="4892040"/>
+            <a:ext cx="1828800" cy="274320"/>
+          </a:xfrm>
+          <a:prstGeom prst="rect">
+            <a:avLst/>
+          </a:prstGeom>
+          <a:noFill/>
+        </p:spPr>
+        <p:txBody>
+          <a:bodyPr wrap="square">
+            <a:spAutoFit/>
+          </a:bodyPr>
+          <a:lstStyle/>
+          <a:p>
+            <a:pPr algn="l">
+              <a:defRPr sz="1000" b="1">
+                <a:solidFill>
+                  <a:srgbClr val="1E88E5"/>
+                </a:solidFill>
+                <a:latin typeface="Calibri"/>
+              </a:defRPr>
+            </a:pPr>
+            <a:r>
+              <a:t>pLIN Codes</a:t>
+            </a:r>
+          </a:p>
+        </p:txBody>
+      </p:sp>
+      <p:sp>
+        <p:nvSpPr>
+          <p:cNvPr id="49" name="TextBox 48"/>
+          <p:cNvSpPr txBox="1"/>
+          <p:nvPr/>
+        </p:nvSpPr>
+        <p:spPr>
+          <a:xfrm>
+            <a:off x="7132320" y="4892040"/>
+            <a:ext cx="1828800" cy="274320"/>
+          </a:xfrm>
+          <a:prstGeom prst="rect">
+            <a:avLst/>
+          </a:prstGeom>
+          <a:noFill/>
+        </p:spPr>
+        <p:txBody>
+          <a:bodyPr wrap="square">
+            <a:spAutoFit/>
+          </a:bodyPr>
+          <a:lstStyle/>
+          <a:p>
+            <a:pPr algn="l">
+              <a:defRPr sz="1000" b="1">
+                <a:solidFill>
+                  <a:srgbClr val="1E88E5"/>
+                </a:solidFill>
+                <a:latin typeface="Calibri"/>
+              </a:defRPr>
+            </a:pPr>
+            <a:r>
+              <a:t>% of Total</a:t>
+            </a:r>
+          </a:p>
+        </p:txBody>
+      </p:sp>
+      <p:sp>
+        <p:nvSpPr>
+          <p:cNvPr id="50" name="TextBox 49"/>
+          <p:cNvSpPr txBox="1"/>
+          <p:nvPr/>
+        </p:nvSpPr>
+        <p:spPr>
+          <a:xfrm>
+            <a:off x="457200" y="5166360"/>
+            <a:ext cx="1828800" cy="228600"/>
+          </a:xfrm>
+          <a:prstGeom prst="rect">
+            <a:avLst/>
+          </a:prstGeom>
+          <a:noFill/>
+        </p:spPr>
+        <p:txBody>
+          <a:bodyPr wrap="square">
+            <a:spAutoFit/>
+          </a:bodyPr>
+          <a:lstStyle/>
+          <a:p>
+            <a:pPr algn="l">
+              <a:defRPr sz="900" b="0">
+                <a:solidFill>
+                  <a:srgbClr val="333333"/>
+                </a:solidFill>
+                <a:latin typeface="Calibri"/>
+              </a:defRPr>
+            </a:pPr>
+            <a:r>
+              <a:t>IncFII</a:t>
+            </a:r>
+          </a:p>
+        </p:txBody>
+      </p:sp>
+      <p:sp>
+        <p:nvSpPr>
+          <p:cNvPr id="51" name="TextBox 50"/>
+          <p:cNvSpPr txBox="1"/>
+          <p:nvPr/>
+        </p:nvSpPr>
+        <p:spPr>
+          <a:xfrm>
+            <a:off x="2560320" y="5166360"/>
+            <a:ext cx="1828800" cy="228600"/>
+          </a:xfrm>
+          <a:prstGeom prst="rect">
+            <a:avLst/>
+          </a:prstGeom>
+          <a:noFill/>
+        </p:spPr>
+        <p:txBody>
+          <a:bodyPr wrap="square">
+            <a:spAutoFit/>
+          </a:bodyPr>
+          <a:lstStyle/>
+          <a:p>
+            <a:pPr algn="l">
+              <a:defRPr sz="900" b="0">
+                <a:solidFill>
+                  <a:srgbClr val="333333"/>
+                </a:solidFill>
+                <a:latin typeface="Calibri"/>
+              </a:defRPr>
+            </a:pPr>
+            <a:r>
+              <a:t>34,036</a:t>
+            </a:r>
+          </a:p>
+        </p:txBody>
+      </p:sp>
+      <p:sp>
+        <p:nvSpPr>
+          <p:cNvPr id="52" name="TextBox 51"/>
+          <p:cNvSpPr txBox="1"/>
+          <p:nvPr/>
+        </p:nvSpPr>
+        <p:spPr>
+          <a:xfrm>
+            <a:off x="4846320" y="5166360"/>
+            <a:ext cx="1828800" cy="228600"/>
+          </a:xfrm>
+          <a:prstGeom prst="rect">
+            <a:avLst/>
+          </a:prstGeom>
+          <a:noFill/>
+        </p:spPr>
+        <p:txBody>
+          <a:bodyPr wrap="square">
+            <a:spAutoFit/>
+          </a:bodyPr>
+          <a:lstStyle/>
+          <a:p>
+            <a:pPr algn="l">
+              <a:defRPr sz="900" b="0">
+                <a:solidFill>
+                  <a:srgbClr val="333333"/>
+                </a:solidFill>
+                <a:latin typeface="Calibri"/>
+              </a:defRPr>
+            </a:pPr>
+            <a:r>
+              <a:t>14,403</a:t>
+            </a:r>
+          </a:p>
+        </p:txBody>
+      </p:sp>
+      <p:sp>
+        <p:nvSpPr>
+          <p:cNvPr id="53" name="TextBox 52"/>
+          <p:cNvSpPr txBox="1"/>
+          <p:nvPr/>
+        </p:nvSpPr>
+        <p:spPr>
+          <a:xfrm>
+            <a:off x="7132320" y="5166360"/>
+            <a:ext cx="1828800" cy="228600"/>
+          </a:xfrm>
+          <a:prstGeom prst="rect">
+            <a:avLst/>
+          </a:prstGeom>
+          <a:noFill/>
+        </p:spPr>
+        <p:txBody>
+          <a:bodyPr wrap="square">
+            <a:spAutoFit/>
+          </a:bodyPr>
+          <a:lstStyle/>
+          <a:p>
+            <a:pPr algn="l">
+              <a:defRPr sz="900" b="0">
+                <a:solidFill>
+                  <a:srgbClr val="333333"/>
+                </a:solidFill>
+                <a:latin typeface="Calibri"/>
+              </a:defRPr>
+            </a:pPr>
+            <a:r>
+              <a:t>43.1%</a:t>
+            </a:r>
+          </a:p>
+        </p:txBody>
+      </p:sp>
+      <p:sp>
+        <p:nvSpPr>
+          <p:cNvPr id="54" name="TextBox 53"/>
+          <p:cNvSpPr txBox="1"/>
+          <p:nvPr/>
+        </p:nvSpPr>
+        <p:spPr>
+          <a:xfrm>
+            <a:off x="457200" y="5440680"/>
+            <a:ext cx="1828800" cy="228600"/>
+          </a:xfrm>
+          <a:prstGeom prst="rect">
+            <a:avLst/>
+          </a:prstGeom>
+          <a:noFill/>
+        </p:spPr>
+        <p:txBody>
+          <a:bodyPr wrap="square">
+            <a:spAutoFit/>
+          </a:bodyPr>
+          <a:lstStyle/>
+          <a:p>
+            <a:pPr algn="l">
+              <a:defRPr sz="900" b="0">
+                <a:solidFill>
+                  <a:srgbClr val="333333"/>
+                </a:solidFill>
+                <a:latin typeface="Calibri"/>
+              </a:defRPr>
+            </a:pPr>
+            <a:r>
+              <a:t>IncX1</a:t>
+            </a:r>
+          </a:p>
+        </p:txBody>
+      </p:sp>
+      <p:sp>
+        <p:nvSpPr>
+          <p:cNvPr id="55" name="TextBox 54"/>
+          <p:cNvSpPr txBox="1"/>
+          <p:nvPr/>
+        </p:nvSpPr>
+        <p:spPr>
+          <a:xfrm>
+            <a:off x="2560320" y="5440680"/>
+            <a:ext cx="1828800" cy="228600"/>
+          </a:xfrm>
+          <a:prstGeom prst="rect">
+            <a:avLst/>
+          </a:prstGeom>
+          <a:noFill/>
+        </p:spPr>
+        <p:txBody>
+          <a:bodyPr wrap="square">
+            <a:spAutoFit/>
+          </a:bodyPr>
+          <a:lstStyle/>
+          <a:p>
+            <a:pPr algn="l">
+              <a:defRPr sz="900" b="0">
+                <a:solidFill>
+                  <a:srgbClr val="333333"/>
+                </a:solidFill>
+                <a:latin typeface="Calibri"/>
+              </a:defRPr>
+            </a:pPr>
+            <a:r>
+              <a:t>26,154</a:t>
+            </a:r>
+          </a:p>
+        </p:txBody>
+      </p:sp>
+      <p:sp>
+        <p:nvSpPr>
+          <p:cNvPr id="56" name="TextBox 55"/>
+          <p:cNvSpPr txBox="1"/>
+          <p:nvPr/>
+        </p:nvSpPr>
+        <p:spPr>
+          <a:xfrm>
+            <a:off x="4846320" y="5440680"/>
+            <a:ext cx="1828800" cy="228600"/>
+          </a:xfrm>
+          <a:prstGeom prst="rect">
+            <a:avLst/>
+          </a:prstGeom>
+          <a:noFill/>
+        </p:spPr>
+        <p:txBody>
+          <a:bodyPr wrap="square">
+            <a:spAutoFit/>
+          </a:bodyPr>
+          <a:lstStyle/>
+          <a:p>
+            <a:pPr algn="l">
+              <a:defRPr sz="900" b="0">
+                <a:solidFill>
+                  <a:srgbClr val="333333"/>
+                </a:solidFill>
+                <a:latin typeface="Calibri"/>
+              </a:defRPr>
+            </a:pPr>
+            <a:r>
+              <a:t>14,060</a:t>
+            </a:r>
+          </a:p>
+        </p:txBody>
+      </p:sp>
+      <p:sp>
+        <p:nvSpPr>
+          <p:cNvPr id="57" name="TextBox 56"/>
+          <p:cNvSpPr txBox="1"/>
+          <p:nvPr/>
+        </p:nvSpPr>
+        <p:spPr>
+          <a:xfrm>
+            <a:off x="7132320" y="5440680"/>
+            <a:ext cx="1828800" cy="228600"/>
+          </a:xfrm>
+          <a:prstGeom prst="rect">
+            <a:avLst/>
+          </a:prstGeom>
+          <a:noFill/>
+        </p:spPr>
+        <p:txBody>
+          <a:bodyPr wrap="square">
+            <a:spAutoFit/>
+          </a:bodyPr>
+          <a:lstStyle/>
+          <a:p>
+            <a:pPr algn="l">
+              <a:defRPr sz="900" b="0">
+                <a:solidFill>
+                  <a:srgbClr val="333333"/>
+                </a:solidFill>
+                <a:latin typeface="Calibri"/>
+              </a:defRPr>
+            </a:pPr>
+            <a:r>
+              <a:t>33.1%</a:t>
+            </a:r>
+          </a:p>
+        </p:txBody>
+      </p:sp>
+      <p:sp>
+        <p:nvSpPr>
+          <p:cNvPr id="58" name="TextBox 57"/>
+          <p:cNvSpPr txBox="1"/>
+          <p:nvPr/>
+        </p:nvSpPr>
+        <p:spPr>
+          <a:xfrm>
+            <a:off x="457200" y="5715000"/>
+            <a:ext cx="1828800" cy="228600"/>
+          </a:xfrm>
+          <a:prstGeom prst="rect">
+            <a:avLst/>
+          </a:prstGeom>
+          <a:noFill/>
+        </p:spPr>
+        <p:txBody>
+          <a:bodyPr wrap="square">
+            <a:spAutoFit/>
+          </a:bodyPr>
+          <a:lstStyle/>
+          <a:p>
+            <a:pPr algn="l">
+              <a:defRPr sz="900" b="0">
+                <a:solidFill>
+                  <a:srgbClr val="333333"/>
+                </a:solidFill>
+                <a:latin typeface="Calibri"/>
+              </a:defRPr>
+            </a:pPr>
+            <a:r>
+              <a:t>IncN</a:t>
+            </a:r>
+          </a:p>
+        </p:txBody>
+      </p:sp>
+      <p:sp>
+        <p:nvSpPr>
+          <p:cNvPr id="59" name="TextBox 58"/>
+          <p:cNvSpPr txBox="1"/>
+          <p:nvPr/>
+        </p:nvSpPr>
+        <p:spPr>
+          <a:xfrm>
+            <a:off x="2560320" y="5715000"/>
+            <a:ext cx="1828800" cy="228600"/>
+          </a:xfrm>
+          <a:prstGeom prst="rect">
+            <a:avLst/>
+          </a:prstGeom>
+          <a:noFill/>
+        </p:spPr>
+        <p:txBody>
+          <a:bodyPr wrap="square">
+            <a:spAutoFit/>
+          </a:bodyPr>
+          <a:lstStyle/>
+          <a:p>
+            <a:pPr algn="l">
+              <a:defRPr sz="900" b="0">
+                <a:solidFill>
+                  <a:srgbClr val="333333"/>
+                </a:solidFill>
+                <a:latin typeface="Calibri"/>
+              </a:defRPr>
+            </a:pPr>
+            <a:r>
+              <a:t>5,303</a:t>
+            </a:r>
+          </a:p>
+        </p:txBody>
+      </p:sp>
+      <p:sp>
+        <p:nvSpPr>
+          <p:cNvPr id="60" name="TextBox 59"/>
+          <p:cNvSpPr txBox="1"/>
+          <p:nvPr/>
+        </p:nvSpPr>
+        <p:spPr>
+          <a:xfrm>
+            <a:off x="4846320" y="5715000"/>
+            <a:ext cx="1828800" cy="228600"/>
+          </a:xfrm>
+          <a:prstGeom prst="rect">
+            <a:avLst/>
+          </a:prstGeom>
+          <a:noFill/>
+        </p:spPr>
+        <p:txBody>
+          <a:bodyPr wrap="square">
+            <a:spAutoFit/>
+          </a:bodyPr>
+          <a:lstStyle/>
+          <a:p>
+            <a:pPr algn="l">
+              <a:defRPr sz="900" b="0">
+                <a:solidFill>
+                  <a:srgbClr val="333333"/>
+                </a:solidFill>
+                <a:latin typeface="Calibri"/>
+              </a:defRPr>
+            </a:pPr>
+            <a:r>
+              <a:t>1,912</a:t>
+            </a:r>
+          </a:p>
+        </p:txBody>
+      </p:sp>
+      <p:sp>
+        <p:nvSpPr>
+          <p:cNvPr id="61" name="TextBox 60"/>
+          <p:cNvSpPr txBox="1"/>
+          <p:nvPr/>
+        </p:nvSpPr>
+        <p:spPr>
+          <a:xfrm>
+            <a:off x="7132320" y="5715000"/>
+            <a:ext cx="1828800" cy="228600"/>
+          </a:xfrm>
+          <a:prstGeom prst="rect">
+            <a:avLst/>
+          </a:prstGeom>
+          <a:noFill/>
+        </p:spPr>
+        <p:txBody>
+          <a:bodyPr wrap="square">
+            <a:spAutoFit/>
+          </a:bodyPr>
+          <a:lstStyle/>
+          <a:p>
+            <a:pPr algn="l">
+              <a:defRPr sz="900" b="0">
+                <a:solidFill>
+                  <a:srgbClr val="333333"/>
+                </a:solidFill>
+                <a:latin typeface="Calibri"/>
+              </a:defRPr>
+            </a:pPr>
+            <a:r>
+              <a:t>6.7%</a:t>
+            </a:r>
+          </a:p>
+        </p:txBody>
+      </p:sp>
+      <p:sp>
+        <p:nvSpPr>
+          <p:cNvPr id="62" name="TextBox 61"/>
+          <p:cNvSpPr txBox="1"/>
+          <p:nvPr/>
+        </p:nvSpPr>
+        <p:spPr>
+          <a:xfrm>
+            <a:off x="457200" y="5989320"/>
+            <a:ext cx="1828800" cy="228600"/>
+          </a:xfrm>
+          <a:prstGeom prst="rect">
+            <a:avLst/>
+          </a:prstGeom>
+          <a:noFill/>
+        </p:spPr>
+        <p:txBody>
+          <a:bodyPr wrap="square">
+            <a:spAutoFit/>
+          </a:bodyPr>
+          <a:lstStyle/>
+          <a:p>
+            <a:pPr algn="l">
+              <a:defRPr sz="900" b="0">
+                <a:solidFill>
+                  <a:srgbClr val="333333"/>
+                </a:solidFill>
+                <a:latin typeface="Calibri"/>
+              </a:defRPr>
+            </a:pPr>
+            <a:r>
+              <a:t>ColRNAI</a:t>
+            </a:r>
+          </a:p>
+        </p:txBody>
+      </p:sp>
+      <p:sp>
+        <p:nvSpPr>
+          <p:cNvPr id="63" name="TextBox 62"/>
+          <p:cNvSpPr txBox="1"/>
+          <p:nvPr/>
+        </p:nvSpPr>
+        <p:spPr>
+          <a:xfrm>
+            <a:off x="2560320" y="5989320"/>
+            <a:ext cx="1828800" cy="228600"/>
+          </a:xfrm>
+          <a:prstGeom prst="rect">
+            <a:avLst/>
+          </a:prstGeom>
+          <a:noFill/>
+        </p:spPr>
+        <p:txBody>
+          <a:bodyPr wrap="square">
+            <a:spAutoFit/>
+          </a:bodyPr>
+          <a:lstStyle/>
+          <a:p>
+            <a:pPr algn="l">
+              <a:defRPr sz="900" b="0">
+                <a:solidFill>
+                  <a:srgbClr val="333333"/>
+                </a:solidFill>
+                <a:latin typeface="Calibri"/>
+              </a:defRPr>
+            </a:pPr>
+            <a:r>
+              <a:t>1,927</a:t>
+            </a:r>
+          </a:p>
+        </p:txBody>
+      </p:sp>
+      <p:sp>
+        <p:nvSpPr>
+          <p:cNvPr id="64" name="TextBox 63"/>
+          <p:cNvSpPr txBox="1"/>
+          <p:nvPr/>
+        </p:nvSpPr>
+        <p:spPr>
+          <a:xfrm>
+            <a:off x="4846320" y="5989320"/>
+            <a:ext cx="1828800" cy="228600"/>
+          </a:xfrm>
+          <a:prstGeom prst="rect">
+            <a:avLst/>
+          </a:prstGeom>
+          <a:noFill/>
+        </p:spPr>
+        <p:txBody>
+          <a:bodyPr wrap="square">
+            <a:spAutoFit/>
+          </a:bodyPr>
+          <a:lstStyle/>
+          <a:p>
+            <a:pPr algn="l">
+              <a:defRPr sz="900" b="0">
+                <a:solidFill>
+                  <a:srgbClr val="333333"/>
+                </a:solidFill>
+                <a:latin typeface="Calibri"/>
+              </a:defRPr>
+            </a:pPr>
+            <a:r>
+              <a:t>618</a:t>
+            </a:r>
+          </a:p>
+        </p:txBody>
+      </p:sp>
+      <p:sp>
+        <p:nvSpPr>
+          <p:cNvPr id="65" name="TextBox 64"/>
+          <p:cNvSpPr txBox="1"/>
+          <p:nvPr/>
+        </p:nvSpPr>
+        <p:spPr>
+          <a:xfrm>
+            <a:off x="7132320" y="5989320"/>
+            <a:ext cx="1828800" cy="228600"/>
+          </a:xfrm>
+          <a:prstGeom prst="rect">
+            <a:avLst/>
+          </a:prstGeom>
+          <a:noFill/>
+        </p:spPr>
+        <p:txBody>
+          <a:bodyPr wrap="square">
+            <a:spAutoFit/>
+          </a:bodyPr>
+          <a:lstStyle/>
+          <a:p>
+            <a:pPr algn="l">
+              <a:defRPr sz="900" b="0">
+                <a:solidFill>
+                  <a:srgbClr val="333333"/>
+                </a:solidFill>
+                <a:latin typeface="Calibri"/>
+              </a:defRPr>
+            </a:pPr>
+            <a:r>
+              <a:t>2.4%</a:t>
+            </a:r>
+          </a:p>
+        </p:txBody>
+      </p:sp>
+      <p:sp>
+        <p:nvSpPr>
+          <p:cNvPr id="66" name="TextBox 65"/>
+          <p:cNvSpPr txBox="1"/>
+          <p:nvPr/>
+        </p:nvSpPr>
+        <p:spPr>
+          <a:xfrm>
+            <a:off x="457200" y="6263640"/>
+            <a:ext cx="1828800" cy="228600"/>
+          </a:xfrm>
+          <a:prstGeom prst="rect">
+            <a:avLst/>
+          </a:prstGeom>
+          <a:noFill/>
+        </p:spPr>
+        <p:txBody>
+          <a:bodyPr wrap="square">
+            <a:spAutoFit/>
+          </a:bodyPr>
+          <a:lstStyle/>
+          <a:p>
+            <a:pPr algn="l">
+              <a:defRPr sz="900" b="0">
+                <a:solidFill>
+                  <a:srgbClr val="333333"/>
+                </a:solidFill>
+                <a:latin typeface="Calibri"/>
+              </a:defRPr>
+            </a:pPr>
+            <a:r>
+              <a:t>IncX3</a:t>
+            </a:r>
+          </a:p>
+        </p:txBody>
+      </p:sp>
+      <p:sp>
+        <p:nvSpPr>
+          <p:cNvPr id="67" name="TextBox 66"/>
+          <p:cNvSpPr txBox="1"/>
+          <p:nvPr/>
+        </p:nvSpPr>
+        <p:spPr>
+          <a:xfrm>
+            <a:off x="2560320" y="6263640"/>
+            <a:ext cx="1828800" cy="228600"/>
+          </a:xfrm>
+          <a:prstGeom prst="rect">
+            <a:avLst/>
+          </a:prstGeom>
+          <a:noFill/>
+        </p:spPr>
+        <p:txBody>
+          <a:bodyPr wrap="square">
+            <a:spAutoFit/>
+          </a:bodyPr>
+          <a:lstStyle/>
+          <a:p>
+            <a:pPr algn="l">
+              <a:defRPr sz="900" b="0">
+                <a:solidFill>
+                  <a:srgbClr val="333333"/>
+                </a:solidFill>
+                <a:latin typeface="Calibri"/>
+              </a:defRPr>
+            </a:pPr>
+            <a:r>
+              <a:t>1,459</a:t>
+            </a:r>
+          </a:p>
+        </p:txBody>
+      </p:sp>
+      <p:sp>
+        <p:nvSpPr>
+          <p:cNvPr id="68" name="TextBox 67"/>
+          <p:cNvSpPr txBox="1"/>
+          <p:nvPr/>
+        </p:nvSpPr>
+        <p:spPr>
+          <a:xfrm>
+            <a:off x="4846320" y="6263640"/>
+            <a:ext cx="1828800" cy="228600"/>
+          </a:xfrm>
+          <a:prstGeom prst="rect">
+            <a:avLst/>
+          </a:prstGeom>
+          <a:noFill/>
+        </p:spPr>
+        <p:txBody>
+          <a:bodyPr wrap="square">
+            <a:spAutoFit/>
+          </a:bodyPr>
+          <a:lstStyle/>
+          <a:p>
+            <a:pPr algn="l">
+              <a:defRPr sz="900" b="0">
+                <a:solidFill>
+                  <a:srgbClr val="333333"/>
+                </a:solidFill>
+                <a:latin typeface="Calibri"/>
+              </a:defRPr>
+            </a:pPr>
+            <a:r>
+              <a:t>323</a:t>
+            </a:r>
+          </a:p>
+        </p:txBody>
+      </p:sp>
+      <p:sp>
+        <p:nvSpPr>
+          <p:cNvPr id="69" name="TextBox 68"/>
+          <p:cNvSpPr txBox="1"/>
+          <p:nvPr/>
+        </p:nvSpPr>
+        <p:spPr>
+          <a:xfrm>
+            <a:off x="7132320" y="6263640"/>
+            <a:ext cx="1828800" cy="228600"/>
+          </a:xfrm>
+          <a:prstGeom prst="rect">
+            <a:avLst/>
+          </a:prstGeom>
+          <a:noFill/>
+        </p:spPr>
+        <p:txBody>
+          <a:bodyPr wrap="square">
+            <a:spAutoFit/>
+          </a:bodyPr>
+          <a:lstStyle/>
+          <a:p>
+            <a:pPr algn="l">
+              <a:defRPr sz="900" b="0">
+                <a:solidFill>
+                  <a:srgbClr val="333333"/>
+                </a:solidFill>
+                <a:latin typeface="Calibri"/>
+              </a:defRPr>
+            </a:pPr>
+            <a:r>
+              <a:t>1.8%</a:t>
+            </a:r>
+          </a:p>
+        </p:txBody>
+      </p:sp>
+      <p:sp>
+        <p:nvSpPr>
+          <p:cNvPr id="70" name="TextBox 69"/>
+          <p:cNvSpPr txBox="1"/>
+          <p:nvPr/>
+        </p:nvSpPr>
+        <p:spPr>
+          <a:xfrm>
+            <a:off x="5943600" y="5166360"/>
+            <a:ext cx="1828800" cy="228600"/>
+          </a:xfrm>
+          <a:prstGeom prst="rect">
+            <a:avLst/>
+          </a:prstGeom>
+          <a:noFill/>
+        </p:spPr>
+        <p:txBody>
+          <a:bodyPr wrap="square">
+            <a:spAutoFit/>
+          </a:bodyPr>
+          <a:lstStyle/>
+          <a:p>
+            <a:pPr algn="l">
+              <a:defRPr sz="900" b="0">
+                <a:solidFill>
+                  <a:srgbClr val="333333"/>
+                </a:solidFill>
+                <a:latin typeface="Calibri"/>
+              </a:defRPr>
+            </a:pPr>
+            <a:r>
+              <a:t>IncFIB</a:t>
+            </a:r>
+          </a:p>
+        </p:txBody>
+      </p:sp>
+      <p:sp>
+        <p:nvSpPr>
+          <p:cNvPr id="71" name="TextBox 70"/>
+          <p:cNvSpPr txBox="1"/>
+          <p:nvPr/>
+        </p:nvSpPr>
+        <p:spPr>
+          <a:xfrm>
+            <a:off x="8046720" y="5166360"/>
+            <a:ext cx="1828800" cy="228600"/>
+          </a:xfrm>
+          <a:prstGeom prst="rect">
+            <a:avLst/>
+          </a:prstGeom>
+          <a:noFill/>
+        </p:spPr>
+        <p:txBody>
+          <a:bodyPr wrap="square">
+            <a:spAutoFit/>
+          </a:bodyPr>
+          <a:lstStyle/>
+          <a:p>
+            <a:pPr algn="l">
+              <a:defRPr sz="900" b="0">
+                <a:solidFill>
+                  <a:srgbClr val="333333"/>
+                </a:solidFill>
+                <a:latin typeface="Calibri"/>
+              </a:defRPr>
+            </a:pPr>
+            <a:r>
+              <a:t>1,119</a:t>
+            </a:r>
+          </a:p>
+        </p:txBody>
+      </p:sp>
+      <p:sp>
+        <p:nvSpPr>
+          <p:cNvPr id="72" name="TextBox 71"/>
+          <p:cNvSpPr txBox="1"/>
+          <p:nvPr/>
+        </p:nvSpPr>
+        <p:spPr>
+          <a:xfrm>
+            <a:off x="10332720" y="5166360"/>
+            <a:ext cx="1828800" cy="228600"/>
+          </a:xfrm>
+          <a:prstGeom prst="rect">
+            <a:avLst/>
+          </a:prstGeom>
+          <a:noFill/>
+        </p:spPr>
+        <p:txBody>
+          <a:bodyPr wrap="square">
+            <a:spAutoFit/>
+          </a:bodyPr>
+          <a:lstStyle/>
+          <a:p>
+            <a:pPr algn="l">
+              <a:defRPr sz="900" b="0">
+                <a:solidFill>
+                  <a:srgbClr val="333333"/>
+                </a:solidFill>
+                <a:latin typeface="Calibri"/>
+              </a:defRPr>
+            </a:pPr>
+            <a:r>
+              <a:t>279</a:t>
+            </a:r>
+          </a:p>
+        </p:txBody>
+      </p:sp>
+      <p:sp>
+        <p:nvSpPr>
+          <p:cNvPr id="73" name="TextBox 72"/>
+          <p:cNvSpPr txBox="1"/>
+          <p:nvPr/>
+        </p:nvSpPr>
+        <p:spPr>
+          <a:xfrm>
+            <a:off x="12618720" y="5166360"/>
+            <a:ext cx="1828800" cy="228600"/>
+          </a:xfrm>
+          <a:prstGeom prst="rect">
+            <a:avLst/>
+          </a:prstGeom>
+          <a:noFill/>
+        </p:spPr>
+        <p:txBody>
+          <a:bodyPr wrap="square">
+            <a:spAutoFit/>
+          </a:bodyPr>
+          <a:lstStyle/>
+          <a:p>
+            <a:pPr algn="l">
+              <a:defRPr sz="900" b="0">
+                <a:solidFill>
+                  <a:srgbClr val="333333"/>
+                </a:solidFill>
+                <a:latin typeface="Calibri"/>
+              </a:defRPr>
+            </a:pPr>
+            <a:r>
+              <a:t>1.4%</a:t>
+            </a:r>
+          </a:p>
+        </p:txBody>
+      </p:sp>
+      <p:sp>
+        <p:nvSpPr>
+          <p:cNvPr id="74" name="TextBox 73"/>
+          <p:cNvSpPr txBox="1"/>
+          <p:nvPr/>
+        </p:nvSpPr>
+        <p:spPr>
+          <a:xfrm>
+            <a:off x="5943600" y="5440680"/>
+            <a:ext cx="1828800" cy="228600"/>
+          </a:xfrm>
+          <a:prstGeom prst="rect">
+            <a:avLst/>
+          </a:prstGeom>
+          <a:noFill/>
+        </p:spPr>
+        <p:txBody>
+          <a:bodyPr wrap="square">
+            <a:spAutoFit/>
+          </a:bodyPr>
+          <a:lstStyle/>
+          <a:p>
+            <a:pPr algn="l">
+              <a:defRPr sz="900" b="0">
+                <a:solidFill>
+                  <a:srgbClr val="333333"/>
+                </a:solidFill>
+                <a:latin typeface="Calibri"/>
+              </a:defRPr>
+            </a:pPr>
+            <a:r>
+              <a:t>IncI1</a:t>
+            </a:r>
+          </a:p>
+        </p:txBody>
+      </p:sp>
+      <p:sp>
+        <p:nvSpPr>
+          <p:cNvPr id="75" name="TextBox 74"/>
+          <p:cNvSpPr txBox="1"/>
+          <p:nvPr/>
+        </p:nvSpPr>
+        <p:spPr>
+          <a:xfrm>
+            <a:off x="8046720" y="5440680"/>
+            <a:ext cx="1828800" cy="228600"/>
+          </a:xfrm>
+          <a:prstGeom prst="rect">
+            <a:avLst/>
+          </a:prstGeom>
+          <a:noFill/>
+        </p:spPr>
+        <p:txBody>
+          <a:bodyPr wrap="square">
+            <a:spAutoFit/>
+          </a:bodyPr>
+          <a:lstStyle/>
+          <a:p>
+            <a:pPr algn="l">
+              <a:defRPr sz="900" b="0">
+                <a:solidFill>
+                  <a:srgbClr val="333333"/>
+                </a:solidFill>
+                <a:latin typeface="Calibri"/>
+              </a:defRPr>
+            </a:pPr>
+            <a:r>
+              <a:t>947</a:t>
+            </a:r>
+          </a:p>
+        </p:txBody>
+      </p:sp>
+      <p:sp>
+        <p:nvSpPr>
+          <p:cNvPr id="76" name="TextBox 75"/>
+          <p:cNvSpPr txBox="1"/>
+          <p:nvPr/>
+        </p:nvSpPr>
+        <p:spPr>
+          <a:xfrm>
+            <a:off x="10332720" y="5440680"/>
+            <a:ext cx="1828800" cy="228600"/>
+          </a:xfrm>
+          <a:prstGeom prst="rect">
+            <a:avLst/>
+          </a:prstGeom>
+          <a:noFill/>
+        </p:spPr>
+        <p:txBody>
+          <a:bodyPr wrap="square">
+            <a:spAutoFit/>
+          </a:bodyPr>
+          <a:lstStyle/>
+          <a:p>
+            <a:pPr algn="l">
+              <a:defRPr sz="900" b="0">
+                <a:solidFill>
+                  <a:srgbClr val="333333"/>
+                </a:solidFill>
+                <a:latin typeface="Calibri"/>
+              </a:defRPr>
+            </a:pPr>
+            <a:r>
+              <a:t>82</a:t>
+            </a:r>
+          </a:p>
+        </p:txBody>
+      </p:sp>
+      <p:sp>
+        <p:nvSpPr>
+          <p:cNvPr id="77" name="TextBox 76"/>
+          <p:cNvSpPr txBox="1"/>
+          <p:nvPr/>
+        </p:nvSpPr>
+        <p:spPr>
+          <a:xfrm>
+            <a:off x="12618720" y="5440680"/>
+            <a:ext cx="1828800" cy="228600"/>
+          </a:xfrm>
+          <a:prstGeom prst="rect">
+            <a:avLst/>
+          </a:prstGeom>
+          <a:noFill/>
+        </p:spPr>
+        <p:txBody>
+          <a:bodyPr wrap="square">
+            <a:spAutoFit/>
+          </a:bodyPr>
+          <a:lstStyle/>
+          <a:p>
+            <a:pPr algn="l">
+              <a:defRPr sz="900" b="0">
+                <a:solidFill>
+                  <a:srgbClr val="333333"/>
+                </a:solidFill>
+                <a:latin typeface="Calibri"/>
+              </a:defRPr>
+            </a:pPr>
+            <a:r>
+              <a:t>1.2%</a:t>
+            </a:r>
+          </a:p>
+        </p:txBody>
+      </p:sp>
+      <p:sp>
+        <p:nvSpPr>
+          <p:cNvPr id="78" name="TextBox 77"/>
+          <p:cNvSpPr txBox="1"/>
+          <p:nvPr/>
+        </p:nvSpPr>
+        <p:spPr>
+          <a:xfrm>
+            <a:off x="5943600" y="5715000"/>
+            <a:ext cx="1828800" cy="228600"/>
+          </a:xfrm>
+          <a:prstGeom prst="rect">
+            <a:avLst/>
+          </a:prstGeom>
+          <a:noFill/>
+        </p:spPr>
+        <p:txBody>
+          <a:bodyPr wrap="square">
+            <a:spAutoFit/>
+          </a:bodyPr>
+          <a:lstStyle/>
+          <a:p>
+            <a:pPr algn="l">
+              <a:defRPr sz="900" b="0">
+                <a:solidFill>
+                  <a:srgbClr val="333333"/>
+                </a:solidFill>
+                <a:latin typeface="Calibri"/>
+              </a:defRPr>
+            </a:pPr>
+            <a:r>
+              <a:t>IncI2</a:t>
+            </a:r>
+          </a:p>
+        </p:txBody>
+      </p:sp>
+      <p:sp>
+        <p:nvSpPr>
+          <p:cNvPr id="79" name="TextBox 78"/>
+          <p:cNvSpPr txBox="1"/>
+          <p:nvPr/>
+        </p:nvSpPr>
+        <p:spPr>
+          <a:xfrm>
+            <a:off x="8046720" y="5715000"/>
+            <a:ext cx="1828800" cy="228600"/>
+          </a:xfrm>
+          <a:prstGeom prst="rect">
+            <a:avLst/>
+          </a:prstGeom>
+          <a:noFill/>
+        </p:spPr>
+        <p:txBody>
+          <a:bodyPr wrap="square">
+            <a:spAutoFit/>
+          </a:bodyPr>
+          <a:lstStyle/>
+          <a:p>
+            <a:pPr algn="l">
+              <a:defRPr sz="900" b="0">
+                <a:solidFill>
+                  <a:srgbClr val="333333"/>
+                </a:solidFill>
+                <a:latin typeface="Calibri"/>
+              </a:defRPr>
+            </a:pPr>
+            <a:r>
+              <a:t>876</a:t>
+            </a:r>
+          </a:p>
+        </p:txBody>
+      </p:sp>
+      <p:sp>
+        <p:nvSpPr>
+          <p:cNvPr id="80" name="TextBox 79"/>
+          <p:cNvSpPr txBox="1"/>
+          <p:nvPr/>
+        </p:nvSpPr>
+        <p:spPr>
+          <a:xfrm>
+            <a:off x="10332720" y="5715000"/>
+            <a:ext cx="1828800" cy="228600"/>
+          </a:xfrm>
+          <a:prstGeom prst="rect">
+            <a:avLst/>
+          </a:prstGeom>
+          <a:noFill/>
+        </p:spPr>
+        <p:txBody>
+          <a:bodyPr wrap="square">
+            <a:spAutoFit/>
+          </a:bodyPr>
+          <a:lstStyle/>
+          <a:p>
+            <a:pPr algn="l">
+              <a:defRPr sz="900" b="0">
+                <a:solidFill>
+                  <a:srgbClr val="333333"/>
+                </a:solidFill>
+                <a:latin typeface="Calibri"/>
+              </a:defRPr>
+            </a:pPr>
+            <a:r>
+              <a:t>229</a:t>
+            </a:r>
+          </a:p>
+        </p:txBody>
+      </p:sp>
+      <p:sp>
+        <p:nvSpPr>
+          <p:cNvPr id="81" name="TextBox 80"/>
+          <p:cNvSpPr txBox="1"/>
+          <p:nvPr/>
+        </p:nvSpPr>
+        <p:spPr>
+          <a:xfrm>
+            <a:off x="12618720" y="5715000"/>
+            <a:ext cx="1828800" cy="228600"/>
+          </a:xfrm>
+          <a:prstGeom prst="rect">
+            <a:avLst/>
+          </a:prstGeom>
+          <a:noFill/>
+        </p:spPr>
+        <p:txBody>
+          <a:bodyPr wrap="square">
+            <a:spAutoFit/>
+          </a:bodyPr>
+          <a:lstStyle/>
+          <a:p>
+            <a:pPr algn="l">
+              <a:defRPr sz="900" b="0">
+                <a:solidFill>
+                  <a:srgbClr val="333333"/>
+                </a:solidFill>
+                <a:latin typeface="Calibri"/>
+              </a:defRPr>
+            </a:pPr>
+            <a:r>
+              <a:t>1.1%</a:t>
+            </a:r>
+          </a:p>
+        </p:txBody>
+      </p:sp>
+      <p:sp>
+        <p:nvSpPr>
+          <p:cNvPr id="82" name="TextBox 81"/>
+          <p:cNvSpPr txBox="1"/>
+          <p:nvPr/>
+        </p:nvSpPr>
+        <p:spPr>
+          <a:xfrm>
+            <a:off x="5943600" y="5989320"/>
+            <a:ext cx="1828800" cy="228600"/>
+          </a:xfrm>
+          <a:prstGeom prst="rect">
+            <a:avLst/>
+          </a:prstGeom>
+          <a:noFill/>
+        </p:spPr>
+        <p:txBody>
+          <a:bodyPr wrap="square">
+            <a:spAutoFit/>
+          </a:bodyPr>
+          <a:lstStyle/>
+          <a:p>
+            <a:pPr algn="l">
+              <a:defRPr sz="900" b="0">
+                <a:solidFill>
+                  <a:srgbClr val="333333"/>
+                </a:solidFill>
+                <a:latin typeface="Calibri"/>
+              </a:defRPr>
+            </a:pPr>
+            <a:r>
+              <a:t>IncHI1</a:t>
+            </a:r>
+          </a:p>
+        </p:txBody>
+      </p:sp>
+      <p:sp>
+        <p:nvSpPr>
+          <p:cNvPr id="83" name="TextBox 82"/>
+          <p:cNvSpPr txBox="1"/>
+          <p:nvPr/>
+        </p:nvSpPr>
+        <p:spPr>
+          <a:xfrm>
+            <a:off x="8046720" y="5989320"/>
+            <a:ext cx="1828800" cy="228600"/>
+          </a:xfrm>
+          <a:prstGeom prst="rect">
+            <a:avLst/>
+          </a:prstGeom>
+          <a:noFill/>
+        </p:spPr>
+        <p:txBody>
+          <a:bodyPr wrap="square">
+            <a:spAutoFit/>
+          </a:bodyPr>
+          <a:lstStyle/>
+          <a:p>
+            <a:pPr algn="l">
+              <a:defRPr sz="900" b="0">
+                <a:solidFill>
+                  <a:srgbClr val="333333"/>
+                </a:solidFill>
+                <a:latin typeface="Calibri"/>
+              </a:defRPr>
+            </a:pPr>
+            <a:r>
+              <a:t>713</a:t>
+            </a:r>
+          </a:p>
+        </p:txBody>
+      </p:sp>
+      <p:sp>
+        <p:nvSpPr>
+          <p:cNvPr id="84" name="TextBox 83"/>
+          <p:cNvSpPr txBox="1"/>
+          <p:nvPr/>
+        </p:nvSpPr>
+        <p:spPr>
+          <a:xfrm>
+            <a:off x="10332720" y="5989320"/>
+            <a:ext cx="1828800" cy="228600"/>
+          </a:xfrm>
+          <a:prstGeom prst="rect">
+            <a:avLst/>
+          </a:prstGeom>
+          <a:noFill/>
+        </p:spPr>
+        <p:txBody>
+          <a:bodyPr wrap="square">
+            <a:spAutoFit/>
+          </a:bodyPr>
+          <a:lstStyle/>
+          <a:p>
+            <a:pPr algn="l">
+              <a:defRPr sz="900" b="0">
+                <a:solidFill>
+                  <a:srgbClr val="333333"/>
+                </a:solidFill>
+                <a:latin typeface="Calibri"/>
+              </a:defRPr>
+            </a:pPr>
+            <a:r>
+              <a:t>115</a:t>
+            </a:r>
+          </a:p>
+        </p:txBody>
+      </p:sp>
+      <p:sp>
+        <p:nvSpPr>
+          <p:cNvPr id="85" name="TextBox 84"/>
+          <p:cNvSpPr txBox="1"/>
+          <p:nvPr/>
+        </p:nvSpPr>
+        <p:spPr>
+          <a:xfrm>
+            <a:off x="12618720" y="5989320"/>
+            <a:ext cx="1828800" cy="228600"/>
+          </a:xfrm>
+          <a:prstGeom prst="rect">
+            <a:avLst/>
+          </a:prstGeom>
+          <a:noFill/>
+        </p:spPr>
+        <p:txBody>
+          <a:bodyPr wrap="square">
+            <a:spAutoFit/>
+          </a:bodyPr>
+          <a:lstStyle/>
+          <a:p>
+            <a:pPr algn="l">
+              <a:defRPr sz="900" b="0">
+                <a:solidFill>
+                  <a:srgbClr val="333333"/>
+                </a:solidFill>
+                <a:latin typeface="Calibri"/>
+              </a:defRPr>
+            </a:pPr>
+            <a:r>
+              <a:t>0.9%</a:t>
+            </a:r>
+          </a:p>
+        </p:txBody>
+      </p:sp>
+      <p:sp>
+        <p:nvSpPr>
+          <p:cNvPr id="86" name="TextBox 85"/>
+          <p:cNvSpPr txBox="1"/>
+          <p:nvPr/>
+        </p:nvSpPr>
+        <p:spPr>
+          <a:xfrm>
+            <a:off x="5943600" y="6263640"/>
+            <a:ext cx="1828800" cy="228600"/>
+          </a:xfrm>
+          <a:prstGeom prst="rect">
+            <a:avLst/>
+          </a:prstGeom>
+          <a:noFill/>
+        </p:spPr>
+        <p:txBody>
+          <a:bodyPr wrap="square">
+            <a:spAutoFit/>
+          </a:bodyPr>
+          <a:lstStyle/>
+          <a:p>
+            <a:pPr algn="l">
+              <a:defRPr sz="900" b="0">
+                <a:solidFill>
+                  <a:srgbClr val="333333"/>
+                </a:solidFill>
+                <a:latin typeface="Calibri"/>
+              </a:defRPr>
+            </a:pPr>
+            <a:r>
+              <a:t>IncAC2</a:t>
+            </a:r>
+          </a:p>
+        </p:txBody>
+      </p:sp>
+      <p:sp>
+        <p:nvSpPr>
+          <p:cNvPr id="87" name="TextBox 86"/>
+          <p:cNvSpPr txBox="1"/>
+          <p:nvPr/>
+        </p:nvSpPr>
+        <p:spPr>
+          <a:xfrm>
+            <a:off x="8046720" y="6263640"/>
+            <a:ext cx="1828800" cy="228600"/>
+          </a:xfrm>
+          <a:prstGeom prst="rect">
+            <a:avLst/>
+          </a:prstGeom>
+          <a:noFill/>
+        </p:spPr>
+        <p:txBody>
+          <a:bodyPr wrap="square">
+            <a:spAutoFit/>
+          </a:bodyPr>
+          <a:lstStyle/>
+          <a:p>
+            <a:pPr algn="l">
+              <a:defRPr sz="900" b="0">
+                <a:solidFill>
+                  <a:srgbClr val="333333"/>
+                </a:solidFill>
+                <a:latin typeface="Calibri"/>
+              </a:defRPr>
+            </a:pPr>
+            <a:r>
+              <a:t>707</a:t>
+            </a:r>
+          </a:p>
+        </p:txBody>
+      </p:sp>
+      <p:sp>
+        <p:nvSpPr>
+          <p:cNvPr id="88" name="TextBox 87"/>
+          <p:cNvSpPr txBox="1"/>
+          <p:nvPr/>
+        </p:nvSpPr>
+        <p:spPr>
+          <a:xfrm>
+            <a:off x="10332720" y="6263640"/>
+            <a:ext cx="1828800" cy="228600"/>
+          </a:xfrm>
+          <a:prstGeom prst="rect">
+            <a:avLst/>
+          </a:prstGeom>
+          <a:noFill/>
+        </p:spPr>
+        <p:txBody>
+          <a:bodyPr wrap="square">
+            <a:spAutoFit/>
+          </a:bodyPr>
+          <a:lstStyle/>
+          <a:p>
+            <a:pPr algn="l">
+              <a:defRPr sz="900" b="0">
+                <a:solidFill>
+                  <a:srgbClr val="333333"/>
+                </a:solidFill>
+                <a:latin typeface="Calibri"/>
+              </a:defRPr>
+            </a:pPr>
+            <a:r>
+              <a:t>262</a:t>
+            </a:r>
+          </a:p>
+        </p:txBody>
+      </p:sp>
+      <p:sp>
+        <p:nvSpPr>
+          <p:cNvPr id="89" name="TextBox 88"/>
+          <p:cNvSpPr txBox="1"/>
+          <p:nvPr/>
+        </p:nvSpPr>
+        <p:spPr>
+          <a:xfrm>
+            <a:off x="12618720" y="6263640"/>
+            <a:ext cx="1828800" cy="228600"/>
+          </a:xfrm>
+          <a:prstGeom prst="rect">
+            <a:avLst/>
+          </a:prstGeom>
+          <a:noFill/>
+        </p:spPr>
+        <p:txBody>
+          <a:bodyPr wrap="square">
+            <a:spAutoFit/>
+          </a:bodyPr>
+          <a:lstStyle/>
+          <a:p>
+            <a:pPr algn="l">
+              <a:defRPr sz="900" b="0">
+                <a:solidFill>
+                  <a:srgbClr val="333333"/>
+                </a:solidFill>
+                <a:latin typeface="Calibri"/>
+              </a:defRPr>
+            </a:pPr>
+            <a:r>
+              <a:t>0.9%</a:t>
+            </a:r>
+          </a:p>
+        </p:txBody>
+      </p:sp>
+      <p:sp>
+        <p:nvSpPr>
+          <p:cNvPr id="90" name="TextBox 89"/>
+          <p:cNvSpPr txBox="1"/>
+          <p:nvPr/>
+        </p:nvSpPr>
+        <p:spPr>
+          <a:xfrm>
+            <a:off x="365760" y="6400800"/>
+            <a:ext cx="10972800" cy="320040"/>
+          </a:xfrm>
+          <a:prstGeom prst="rect">
+            <a:avLst/>
+          </a:prstGeom>
+          <a:noFill/>
+        </p:spPr>
+        <p:txBody>
+          <a:bodyPr wrap="square">
+            <a:spAutoFit/>
+          </a:bodyPr>
+          <a:lstStyle/>
+          <a:p>
+            <a:pPr algn="l">
+              <a:defRPr sz="1000" b="0">
+                <a:solidFill>
+                  <a:srgbClr val="757575"/>
+                </a:solidFill>
+                <a:latin typeface="Calibri"/>
+              </a:defRPr>
+            </a:pPr>
+            <a:r>
+              <a:t>78.4% singletons (25,988 unique) | Largest cluster: 3,035 sequences | Mean plasmid size: 101 kb | Mean Inc confidence: 83.0%</a:t>
             </a:r>
           </a:p>
         </p:txBody>

</xml_diff>